<commit_message>
Powers fin de la primera clase de la mañan
</commit_message>
<xml_diff>
--- a/LabBook_020.pptx
+++ b/LabBook_020.pptx
@@ -5,17 +5,19 @@
     <p:sldMasterId id="2147483648" r:id="rId1"/>
   </p:sldMasterIdLst>
   <p:notesMasterIdLst>
-    <p:notesMasterId r:id="rId7"/>
+    <p:notesMasterId r:id="rId9"/>
   </p:notesMasterIdLst>
   <p:handoutMasterIdLst>
-    <p:handoutMasterId r:id="rId8"/>
+    <p:handoutMasterId r:id="rId10"/>
   </p:handoutMasterIdLst>
   <p:sldIdLst>
     <p:sldId id="256" r:id="rId2"/>
     <p:sldId id="289" r:id="rId3"/>
     <p:sldId id="290" r:id="rId4"/>
-    <p:sldId id="293" r:id="rId5"/>
-    <p:sldId id="288" r:id="rId6"/>
+    <p:sldId id="294" r:id="rId5"/>
+    <p:sldId id="293" r:id="rId6"/>
+    <p:sldId id="295" r:id="rId7"/>
+    <p:sldId id="288" r:id="rId8"/>
   </p:sldIdLst>
   <p:sldSz cx="12192000" cy="6858000"/>
   <p:notesSz cx="12192000" cy="6858000"/>
@@ -297,7 +299,7 @@
           <a:p>
             <a:fld id="{8438F8DC-35B0-48E6-A86E-42F1F08DD00F}" type="datetimeFigureOut">
               <a:rPr lang="es-ES" smtClean="0"/>
-              <a:t>03/02/2026</a:t>
+              <a:t>16/02/2026</a:t>
             </a:fld>
             <a:endParaRPr lang="es-ES"/>
           </a:p>
@@ -390,6 +392,242 @@
   </p:cSld>
   <p:clrMap bg1="lt1" tx1="dk1" bg2="lt2" tx2="dk2" accent1="accent1" accent2="accent2" accent3="accent3" accent4="accent4" accent5="accent5" accent6="accent6" hlink="hlink" folHlink="folHlink"/>
 </p:handoutMaster>
+</file>
+
+<file path=ppt/ink/ink1.xml><?xml version="1.0" encoding="utf-8"?>
+<inkml:ink xmlns:inkml="http://www.w3.org/2003/InkML">
+  <inkml:definitions>
+    <inkml:context xml:id="ctx0">
+      <inkml:inkSource xml:id="inkSrc0">
+        <inkml:traceFormat>
+          <inkml:channel name="X" type="integer" min="-2.14748E9" max="2.14748E9" units="cm"/>
+          <inkml:channel name="Y" type="integer" min="-2.14748E9" max="2.14748E9" units="cm"/>
+        </inkml:traceFormat>
+        <inkml:channelProperties>
+          <inkml:channelProperty channel="X" name="resolution" value="1000" units="1/cm"/>
+          <inkml:channelProperty channel="Y" name="resolution" value="1000" units="1/cm"/>
+        </inkml:channelProperties>
+      </inkml:inkSource>
+      <inkml:timestamp xml:id="ts0" timeString="2026-02-16T09:54:18.082"/>
+    </inkml:context>
+    <inkml:brush xml:id="br0">
+      <inkml:brushProperty name="width" value="0.3" units="cm"/>
+      <inkml:brushProperty name="height" value="0.6" units="cm"/>
+      <inkml:brushProperty name="color" value="#FFFC00"/>
+      <inkml:brushProperty name="tip" value="rectangle"/>
+      <inkml:brushProperty name="rasterOp" value="maskPen"/>
+      <inkml:brushProperty name="ignorePressure" value="1"/>
+    </inkml:brush>
+  </inkml:definitions>
+  <inkml:trace contextRef="#ctx0" brushRef="#br0">0 158,'131'-3,"-1"-5,0-6,242-58,-278 52,1 5,97-5,240 14,-247 8,-130 1,0 3,0 1,103 29,-111-26,0-3,1-2,63-1,-36-1,66 10,-51-3,-4-1,156 9,625-19,-689-12,3-1,-109 16,95 13,-109-9,90-4,1 1,-56 9,-57-6,43 1,283-8,-192-23,-24 2,-36 11,133-9,-44 7,14 0,427 14,-601-3,52-9,18-1,409 9,-266 5,808-2,-1032-1,0-2,27-6,-23 3,33-1,406 4,-243 5,-177 3,-29 1</inkml:trace>
+</inkml:ink>
+</file>
+
+<file path=ppt/ink/ink2.xml><?xml version="1.0" encoding="utf-8"?>
+<inkml:ink xmlns:inkml="http://www.w3.org/2003/InkML">
+  <inkml:definitions>
+    <inkml:context xml:id="ctx0">
+      <inkml:inkSource xml:id="inkSrc0">
+        <inkml:traceFormat>
+          <inkml:channel name="X" type="integer" min="-2.14748E9" max="2.14748E9" units="cm"/>
+          <inkml:channel name="Y" type="integer" min="-2.14748E9" max="2.14748E9" units="cm"/>
+        </inkml:traceFormat>
+        <inkml:channelProperties>
+          <inkml:channelProperty channel="X" name="resolution" value="1000" units="1/cm"/>
+          <inkml:channelProperty channel="Y" name="resolution" value="1000" units="1/cm"/>
+        </inkml:channelProperties>
+      </inkml:inkSource>
+      <inkml:timestamp xml:id="ts0" timeString="2026-02-16T09:54:34.402"/>
+    </inkml:context>
+    <inkml:brush xml:id="br0">
+      <inkml:brushProperty name="width" value="0.3" units="cm"/>
+      <inkml:brushProperty name="height" value="0.6" units="cm"/>
+      <inkml:brushProperty name="color" value="#FFFC00"/>
+      <inkml:brushProperty name="tip" value="rectangle"/>
+      <inkml:brushProperty name="rasterOp" value="maskPen"/>
+      <inkml:brushProperty name="ignorePressure" value="1"/>
+    </inkml:brush>
+  </inkml:definitions>
+  <inkml:trace contextRef="#ctx0" brushRef="#br0">0 50,'187'-14,"293"42,-358-17,-5-7,223-22,-288 13,118-21,-117 15,1 3,67-2,231 20,-21 1,-325-11</inkml:trace>
+</inkml:ink>
+</file>
+
+<file path=ppt/ink/ink3.xml><?xml version="1.0" encoding="utf-8"?>
+<inkml:ink xmlns:inkml="http://www.w3.org/2003/InkML">
+  <inkml:definitions>
+    <inkml:context xml:id="ctx0">
+      <inkml:inkSource xml:id="inkSrc0">
+        <inkml:traceFormat>
+          <inkml:channel name="X" type="integer" min="-2.14748E9" max="2.14748E9" units="cm"/>
+          <inkml:channel name="Y" type="integer" min="-2.14748E9" max="2.14748E9" units="cm"/>
+        </inkml:traceFormat>
+        <inkml:channelProperties>
+          <inkml:channelProperty channel="X" name="resolution" value="1000" units="1/cm"/>
+          <inkml:channelProperty channel="Y" name="resolution" value="1000" units="1/cm"/>
+        </inkml:channelProperties>
+      </inkml:inkSource>
+      <inkml:timestamp xml:id="ts0" timeString="2026-02-16T09:54:37.995"/>
+    </inkml:context>
+    <inkml:brush xml:id="br0">
+      <inkml:brushProperty name="width" value="0.3" units="cm"/>
+      <inkml:brushProperty name="height" value="0.6" units="cm"/>
+      <inkml:brushProperty name="color" value="#FFFC00"/>
+      <inkml:brushProperty name="tip" value="rectangle"/>
+      <inkml:brushProperty name="rasterOp" value="maskPen"/>
+      <inkml:brushProperty name="ignorePressure" value="1"/>
+    </inkml:brush>
+  </inkml:definitions>
+  <inkml:trace contextRef="#ctx0" brushRef="#br0">0 36,'69'3,"102"18,48 4,273-24,-257-2,-157-2,83-15,-85 7,93 0,63 1,-9-1,-218 11,1-1,-1 0,0 0,0 0,0-1,6-3,-7 4,-1-1,1 1,-1-1,1 1,0 0,-1 1,1-1,0 1,0-1,-1 1,1 0,7 1,-7 1</inkml:trace>
+</inkml:ink>
+</file>
+
+<file path=ppt/ink/ink4.xml><?xml version="1.0" encoding="utf-8"?>
+<inkml:ink xmlns:inkml="http://www.w3.org/2003/InkML">
+  <inkml:definitions>
+    <inkml:context xml:id="ctx0">
+      <inkml:inkSource xml:id="inkSrc0">
+        <inkml:traceFormat>
+          <inkml:channel name="X" type="integer" min="-2.14748E9" max="2.14748E9" units="cm"/>
+          <inkml:channel name="Y" type="integer" min="-2.14748E9" max="2.14748E9" units="cm"/>
+          <inkml:channel name="F" type="integer" max="32767" units="dev"/>
+        </inkml:traceFormat>
+        <inkml:channelProperties>
+          <inkml:channelProperty channel="X" name="resolution" value="1000" units="1/cm"/>
+          <inkml:channelProperty channel="Y" name="resolution" value="1000" units="1/cm"/>
+          <inkml:channelProperty channel="F" name="resolution" value="0" units="1/dev"/>
+        </inkml:channelProperties>
+      </inkml:inkSource>
+      <inkml:timestamp xml:id="ts0" timeString="2026-02-16T09:54:54.022"/>
+    </inkml:context>
+    <inkml:brush xml:id="br0">
+      <inkml:brushProperty name="width" value="0.3" units="cm"/>
+      <inkml:brushProperty name="height" value="0.6" units="cm"/>
+      <inkml:brushProperty name="color" value="#FFFC00"/>
+      <inkml:brushProperty name="tip" value="rectangle"/>
+      <inkml:brushProperty name="rasterOp" value="maskPen"/>
+      <inkml:brushProperty name="ignorePressure" value="1"/>
+    </inkml:brush>
+  </inkml:definitions>
+  <inkml:trace contextRef="#ctx0" brushRef="#br0">1 1 0,'7437'0'0</inkml:trace>
+</inkml:ink>
+</file>
+
+<file path=ppt/ink/ink5.xml><?xml version="1.0" encoding="utf-8"?>
+<inkml:ink xmlns:inkml="http://www.w3.org/2003/InkML">
+  <inkml:definitions>
+    <inkml:context xml:id="ctx0">
+      <inkml:inkSource xml:id="inkSrc0">
+        <inkml:traceFormat>
+          <inkml:channel name="X" type="integer" min="-2.14748E9" max="2.14748E9" units="cm"/>
+          <inkml:channel name="Y" type="integer" min="-2.14748E9" max="2.14748E9" units="cm"/>
+        </inkml:traceFormat>
+        <inkml:channelProperties>
+          <inkml:channelProperty channel="X" name="resolution" value="1000" units="1/cm"/>
+          <inkml:channelProperty channel="Y" name="resolution" value="1000" units="1/cm"/>
+        </inkml:channelProperties>
+      </inkml:inkSource>
+      <inkml:timestamp xml:id="ts0" timeString="2026-02-16T09:54:57.880"/>
+    </inkml:context>
+    <inkml:brush xml:id="br0">
+      <inkml:brushProperty name="width" value="0.3" units="cm"/>
+      <inkml:brushProperty name="height" value="0.6" units="cm"/>
+      <inkml:brushProperty name="color" value="#FFFC00"/>
+      <inkml:brushProperty name="tip" value="rectangle"/>
+      <inkml:brushProperty name="rasterOp" value="maskPen"/>
+      <inkml:brushProperty name="ignorePressure" value="1"/>
+    </inkml:brush>
+  </inkml:definitions>
+  <inkml:trace contextRef="#ctx0" brushRef="#br0">1 30,'218'-15,"-2"1,-41 13,191 25,-109-3,-178-16,-26-4,0-2,56-9,-96 8,142-10,-93 7,107 5,-68 2,0-9,-72 4,0 1,0 1,36 4,13 0,-72-4</inkml:trace>
+</inkml:ink>
+</file>
+
+<file path=ppt/ink/ink6.xml><?xml version="1.0" encoding="utf-8"?>
+<inkml:ink xmlns:inkml="http://www.w3.org/2003/InkML">
+  <inkml:definitions>
+    <inkml:context xml:id="ctx0">
+      <inkml:inkSource xml:id="inkSrc0">
+        <inkml:traceFormat>
+          <inkml:channel name="X" type="integer" min="-2.14748E9" max="2.14748E9" units="cm"/>
+          <inkml:channel name="Y" type="integer" min="-2.14748E9" max="2.14748E9" units="cm"/>
+          <inkml:channel name="F" type="integer" max="32767" units="dev"/>
+        </inkml:traceFormat>
+        <inkml:channelProperties>
+          <inkml:channelProperty channel="X" name="resolution" value="1000" units="1/cm"/>
+          <inkml:channelProperty channel="Y" name="resolution" value="1000" units="1/cm"/>
+          <inkml:channelProperty channel="F" name="resolution" value="0" units="1/dev"/>
+        </inkml:channelProperties>
+      </inkml:inkSource>
+      <inkml:timestamp xml:id="ts0" timeString="2026-02-16T09:55:19.437"/>
+    </inkml:context>
+    <inkml:brush xml:id="br0">
+      <inkml:brushProperty name="width" value="0.2" units="cm"/>
+      <inkml:brushProperty name="height" value="0.4" units="cm"/>
+      <inkml:brushProperty name="color" value="#FFFC00"/>
+      <inkml:brushProperty name="tip" value="rectangle"/>
+      <inkml:brushProperty name="rasterOp" value="maskPen"/>
+      <inkml:brushProperty name="ignorePressure" value="1"/>
+    </inkml:brush>
+  </inkml:definitions>
+  <inkml:trace contextRef="#ctx0" brushRef="#br0">0 0 0,'7684'0'0</inkml:trace>
+</inkml:ink>
+</file>
+
+<file path=ppt/ink/ink7.xml><?xml version="1.0" encoding="utf-8"?>
+<inkml:ink xmlns:inkml="http://www.w3.org/2003/InkML">
+  <inkml:definitions>
+    <inkml:context xml:id="ctx0">
+      <inkml:inkSource xml:id="inkSrc0">
+        <inkml:traceFormat>
+          <inkml:channel name="X" type="integer" min="-2.14748E9" max="2.14748E9" units="cm"/>
+          <inkml:channel name="Y" type="integer" min="-2.14748E9" max="2.14748E9" units="cm"/>
+        </inkml:traceFormat>
+        <inkml:channelProperties>
+          <inkml:channelProperty channel="X" name="resolution" value="1000" units="1/cm"/>
+          <inkml:channelProperty channel="Y" name="resolution" value="1000" units="1/cm"/>
+        </inkml:channelProperties>
+      </inkml:inkSource>
+      <inkml:timestamp xml:id="ts0" timeString="2026-02-16T09:55:24.070"/>
+    </inkml:context>
+    <inkml:brush xml:id="br0">
+      <inkml:brushProperty name="width" value="0.2" units="cm"/>
+      <inkml:brushProperty name="height" value="0.4" units="cm"/>
+      <inkml:brushProperty name="color" value="#FFFC00"/>
+      <inkml:brushProperty name="tip" value="rectangle"/>
+      <inkml:brushProperty name="rasterOp" value="maskPen"/>
+      <inkml:brushProperty name="ignorePressure" value="1"/>
+    </inkml:brush>
+  </inkml:definitions>
+  <inkml:trace contextRef="#ctx0" brushRef="#br0">0 4,'210'-3,"150"3,70 26,-227-20,-128-6,109 12,-74 0,112-3,-151-8,330 6,-331-1,-56-4,0 0,1-1,-1-1,0 0,1 0,-1-2,23-4,-32 3,-1 1</inkml:trace>
+</inkml:ink>
+</file>
+
+<file path=ppt/ink/ink8.xml><?xml version="1.0" encoding="utf-8"?>
+<inkml:ink xmlns:inkml="http://www.w3.org/2003/InkML">
+  <inkml:definitions>
+    <inkml:context xml:id="ctx0">
+      <inkml:inkSource xml:id="inkSrc0">
+        <inkml:traceFormat>
+          <inkml:channel name="X" type="integer" min="-2.14748E9" max="2.14748E9" units="cm"/>
+          <inkml:channel name="Y" type="integer" min="-2.14748E9" max="2.14748E9" units="cm"/>
+        </inkml:traceFormat>
+        <inkml:channelProperties>
+          <inkml:channelProperty channel="X" name="resolution" value="1000" units="1/cm"/>
+          <inkml:channelProperty channel="Y" name="resolution" value="1000" units="1/cm"/>
+        </inkml:channelProperties>
+      </inkml:inkSource>
+      <inkml:timestamp xml:id="ts0" timeString="2026-02-16T09:55:26.236"/>
+    </inkml:context>
+    <inkml:brush xml:id="br0">
+      <inkml:brushProperty name="width" value="0.2" units="cm"/>
+      <inkml:brushProperty name="height" value="0.4" units="cm"/>
+      <inkml:brushProperty name="color" value="#FFFC00"/>
+      <inkml:brushProperty name="tip" value="rectangle"/>
+      <inkml:brushProperty name="rasterOp" value="maskPen"/>
+      <inkml:brushProperty name="ignorePressure" value="1"/>
+    </inkml:brush>
+  </inkml:definitions>
+  <inkml:trace contextRef="#ctx0" brushRef="#br0">0 1,'501'21,"-262"4,220 14,-300-41,-81-1,83 9,-76 5,-51-5,0-2,1-1,0-2,39-4,98-3,-29 3,-132 2,-1 0,0 1,0 1,1-1,-1 2,0-1,0 1,0 1,0 0,17 8,-22-9</inkml:trace>
+</inkml:ink>
 </file>
 
 <file path=ppt/notesMasters/notesMaster1.xml><?xml version="1.0" encoding="utf-8"?>
@@ -474,7 +712,7 @@
           <a:p>
             <a:fld id="{FACBDC12-F39B-4B97-8F4D-6734F9D366FF}" type="datetimeFigureOut">
               <a:rPr lang="es-ES" smtClean="0"/>
-              <a:t>03/02/2026</a:t>
+              <a:t>16/02/2026</a:t>
             </a:fld>
             <a:endParaRPr lang="es-ES"/>
           </a:p>
@@ -914,7 +1152,7 @@
           <a:p>
             <a:fld id="{676223B9-C868-4436-87D9-1A3152E1157A}" type="slidenum">
               <a:rPr lang="es-ES" smtClean="0"/>
-              <a:t>4</a:t>
+              <a:t>5</a:t>
             </a:fld>
             <a:endParaRPr lang="es-ES"/>
           </a:p>
@@ -5039,7 +5277,7 @@
         <p:spPr>
           <a:xfrm>
             <a:off x="609441" y="4860334"/>
-            <a:ext cx="11199971" cy="1200329"/>
+            <a:ext cx="11199971" cy="830997"/>
           </a:xfrm>
           <a:prstGeom prst="rect">
             <a:avLst/>
@@ -5067,33 +5305,8 @@
                 <a:latin typeface="Arial" panose="020B0604020202020204" pitchFamily="34" charset="0"/>
                 <a:cs typeface="Arial" panose="020B0604020202020204" pitchFamily="34" charset="0"/>
               </a:rPr>
-              <a:t>Document all your results (neff, plot fields </a:t>
-            </a:r>
-            <a:r>
-              <a:rPr lang="en-US" sz="1200">
-                <a:latin typeface="Arial" panose="020B0604020202020204" pitchFamily="34" charset="0"/>
-                <a:cs typeface="Arial" panose="020B0604020202020204" pitchFamily="34" charset="0"/>
-              </a:rPr>
-              <a:t>of different modes, </a:t>
-            </a:r>
-            <a:r>
-              <a:rPr lang="en-US" sz="1200" dirty="0">
-                <a:latin typeface="Arial" panose="020B0604020202020204" pitchFamily="34" charset="0"/>
-                <a:cs typeface="Arial" panose="020B0604020202020204" pitchFamily="34" charset="0"/>
-              </a:rPr>
-              <a:t>comparison between </a:t>
-            </a:r>
-            <a:r>
-              <a:rPr lang="en-US" sz="1200">
-                <a:latin typeface="Arial" panose="020B0604020202020204" pitchFamily="34" charset="0"/>
-                <a:cs typeface="Arial" panose="020B0604020202020204" pitchFamily="34" charset="0"/>
-              </a:rPr>
-              <a:t>different polarizations…)</a:t>
-            </a:r>
-            <a:endParaRPr lang="en-US" sz="1200" dirty="0">
-              <a:latin typeface="Arial" panose="020B0604020202020204" pitchFamily="34" charset="0"/>
-              <a:cs typeface="Arial" panose="020B0604020202020204" pitchFamily="34" charset="0"/>
-            </a:endParaRPr>
+              <a:t>Document all your results (neff, plot fields of different modes, comparison between different polarizations…)</a:t>
+            </a:r>
           </a:p>
           <a:p>
             <a:pPr algn="just"/>
@@ -5116,18 +5329,754 @@
               <a:cs typeface="Arial" panose="020B0604020202020204" pitchFamily="34" charset="0"/>
             </a:endParaRPr>
           </a:p>
+        </p:txBody>
+      </p:sp>
+      <p:sp>
+        <p:nvSpPr>
+          <p:cNvPr id="5" name="CuadroTexto 4">
+            <a:extLst>
+              <a:ext uri="{FF2B5EF4-FFF2-40B4-BE49-F238E27FC236}">
+                <a16:creationId xmlns:a16="http://schemas.microsoft.com/office/drawing/2014/main" id="{ED5709B7-BFDF-D2FF-D47D-D25FE8ED2719}"/>
+              </a:ext>
+            </a:extLst>
+          </p:cNvPr>
+          <p:cNvSpPr txBox="1"/>
+          <p:nvPr/>
+        </p:nvSpPr>
+        <p:spPr>
+          <a:xfrm>
+            <a:off x="534989" y="3473730"/>
+            <a:ext cx="11506199" cy="1384995"/>
+          </a:xfrm>
+          <a:prstGeom prst="rect">
+            <a:avLst/>
+          </a:prstGeom>
+          <a:noFill/>
+        </p:spPr>
+        <p:txBody>
+          <a:bodyPr wrap="square" rtlCol="0">
+            <a:spAutoFit/>
+          </a:bodyPr>
+          <a:lstStyle/>
           <a:p>
             <a:pPr algn="just"/>
+            <a:r>
+              <a:rPr lang="en-US" sz="1200" dirty="0">
+                <a:solidFill>
+                  <a:srgbClr val="FF0000"/>
+                </a:solidFill>
+                <a:latin typeface="Arial" panose="020B0604020202020204" pitchFamily="34" charset="0"/>
+                <a:cs typeface="Arial" panose="020B0604020202020204" pitchFamily="34" charset="0"/>
+              </a:rPr>
+              <a:t>Para 20um hay mas de 20 </a:t>
+            </a:r>
+            <a:r>
+              <a:rPr lang="en-US" sz="1200" dirty="0" err="1">
+                <a:solidFill>
+                  <a:srgbClr val="FF0000"/>
+                </a:solidFill>
+                <a:latin typeface="Arial" panose="020B0604020202020204" pitchFamily="34" charset="0"/>
+                <a:cs typeface="Arial" panose="020B0604020202020204" pitchFamily="34" charset="0"/>
+              </a:rPr>
+              <a:t>modos</a:t>
+            </a:r>
+            <a:r>
+              <a:rPr lang="en-US" sz="1200" dirty="0">
+                <a:solidFill>
+                  <a:srgbClr val="FF0000"/>
+                </a:solidFill>
+                <a:latin typeface="Arial" panose="020B0604020202020204" pitchFamily="34" charset="0"/>
+                <a:cs typeface="Arial" panose="020B0604020202020204" pitchFamily="34" charset="0"/>
+              </a:rPr>
+              <a:t> </a:t>
+            </a:r>
+            <a:r>
+              <a:rPr lang="en-US" sz="1200" dirty="0" err="1">
+                <a:solidFill>
+                  <a:srgbClr val="FF0000"/>
+                </a:solidFill>
+                <a:latin typeface="Arial" panose="020B0604020202020204" pitchFamily="34" charset="0"/>
+                <a:cs typeface="Arial" panose="020B0604020202020204" pitchFamily="34" charset="0"/>
+              </a:rPr>
+              <a:t>propagandose</a:t>
+            </a:r>
+            <a:r>
+              <a:rPr lang="en-US" sz="1200" dirty="0">
+                <a:solidFill>
+                  <a:srgbClr val="FF0000"/>
+                </a:solidFill>
+                <a:latin typeface="Arial" panose="020B0604020202020204" pitchFamily="34" charset="0"/>
+                <a:cs typeface="Arial" panose="020B0604020202020204" pitchFamily="34" charset="0"/>
+              </a:rPr>
+              <a:t> (</a:t>
+            </a:r>
+            <a:r>
+              <a:rPr lang="en-US" sz="1200" dirty="0" err="1">
+                <a:solidFill>
+                  <a:srgbClr val="FF0000"/>
+                </a:solidFill>
+                <a:latin typeface="Arial" panose="020B0604020202020204" pitchFamily="34" charset="0"/>
+                <a:cs typeface="Arial" panose="020B0604020202020204" pitchFamily="34" charset="0"/>
+              </a:rPr>
+              <a:t>sacar</a:t>
+            </a:r>
+            <a:r>
+              <a:rPr lang="en-US" sz="1200" dirty="0">
+                <a:solidFill>
+                  <a:srgbClr val="FF0000"/>
+                </a:solidFill>
+                <a:latin typeface="Arial" panose="020B0604020202020204" pitchFamily="34" charset="0"/>
+                <a:cs typeface="Arial" panose="020B0604020202020204" pitchFamily="34" charset="0"/>
+              </a:rPr>
+              <a:t> </a:t>
+            </a:r>
+            <a:r>
+              <a:rPr lang="en-US" sz="1200" dirty="0" err="1">
+                <a:solidFill>
+                  <a:srgbClr val="FF0000"/>
+                </a:solidFill>
+                <a:latin typeface="Arial" panose="020B0604020202020204" pitchFamily="34" charset="0"/>
+                <a:cs typeface="Arial" panose="020B0604020202020204" pitchFamily="34" charset="0"/>
+              </a:rPr>
+              <a:t>numero</a:t>
+            </a:r>
+            <a:r>
+              <a:rPr lang="en-US" sz="1200" dirty="0">
+                <a:solidFill>
+                  <a:srgbClr val="FF0000"/>
+                </a:solidFill>
+                <a:latin typeface="Arial" panose="020B0604020202020204" pitchFamily="34" charset="0"/>
+                <a:cs typeface="Arial" panose="020B0604020202020204" pitchFamily="34" charset="0"/>
+              </a:rPr>
+              <a:t> de </a:t>
+            </a:r>
+            <a:r>
+              <a:rPr lang="en-US" sz="1200" dirty="0" err="1">
+                <a:solidFill>
+                  <a:srgbClr val="FF0000"/>
+                </a:solidFill>
+                <a:latin typeface="Arial" panose="020B0604020202020204" pitchFamily="34" charset="0"/>
+                <a:cs typeface="Arial" panose="020B0604020202020204" pitchFamily="34" charset="0"/>
+              </a:rPr>
+              <a:t>modos</a:t>
+            </a:r>
+            <a:r>
+              <a:rPr lang="en-US" sz="1200" dirty="0">
+                <a:solidFill>
+                  <a:srgbClr val="FF0000"/>
+                </a:solidFill>
+                <a:latin typeface="Arial" panose="020B0604020202020204" pitchFamily="34" charset="0"/>
+                <a:cs typeface="Arial" panose="020B0604020202020204" pitchFamily="34" charset="0"/>
+              </a:rPr>
+              <a:t>), </a:t>
+            </a:r>
+            <a:r>
+              <a:rPr lang="en-US" sz="1200" dirty="0" err="1">
+                <a:solidFill>
+                  <a:srgbClr val="FF0000"/>
+                </a:solidFill>
+                <a:latin typeface="Arial" panose="020B0604020202020204" pitchFamily="34" charset="0"/>
+                <a:cs typeface="Arial" panose="020B0604020202020204" pitchFamily="34" charset="0"/>
+              </a:rPr>
+              <a:t>que</a:t>
+            </a:r>
+            <a:r>
+              <a:rPr lang="en-US" sz="1200" dirty="0">
+                <a:solidFill>
+                  <a:srgbClr val="FF0000"/>
+                </a:solidFill>
+                <a:latin typeface="Arial" panose="020B0604020202020204" pitchFamily="34" charset="0"/>
+                <a:cs typeface="Arial" panose="020B0604020202020204" pitchFamily="34" charset="0"/>
+              </a:rPr>
+              <a:t> </a:t>
+            </a:r>
+            <a:r>
+              <a:rPr lang="en-US" sz="1200" dirty="0" err="1">
+                <a:solidFill>
+                  <a:srgbClr val="FF0000"/>
+                </a:solidFill>
+                <a:latin typeface="Arial" panose="020B0604020202020204" pitchFamily="34" charset="0"/>
+                <a:cs typeface="Arial" panose="020B0604020202020204" pitchFamily="34" charset="0"/>
+              </a:rPr>
+              <a:t>interactuan</a:t>
+            </a:r>
+            <a:r>
+              <a:rPr lang="en-US" sz="1200" dirty="0">
+                <a:solidFill>
+                  <a:srgbClr val="FF0000"/>
+                </a:solidFill>
+                <a:latin typeface="Arial" panose="020B0604020202020204" pitchFamily="34" charset="0"/>
+                <a:cs typeface="Arial" panose="020B0604020202020204" pitchFamily="34" charset="0"/>
+              </a:rPr>
+              <a:t> entre </a:t>
+            </a:r>
+            <a:r>
+              <a:rPr lang="en-US" sz="1200" dirty="0" err="1">
+                <a:solidFill>
+                  <a:srgbClr val="FF0000"/>
+                </a:solidFill>
+                <a:latin typeface="Arial" panose="020B0604020202020204" pitchFamily="34" charset="0"/>
+                <a:cs typeface="Arial" panose="020B0604020202020204" pitchFamily="34" charset="0"/>
+              </a:rPr>
+              <a:t>ellos</a:t>
+            </a:r>
+            <a:r>
+              <a:rPr lang="en-US" sz="1200" dirty="0">
+                <a:solidFill>
+                  <a:srgbClr val="FF0000"/>
+                </a:solidFill>
+                <a:latin typeface="Arial" panose="020B0604020202020204" pitchFamily="34" charset="0"/>
+                <a:cs typeface="Arial" panose="020B0604020202020204" pitchFamily="34" charset="0"/>
+              </a:rPr>
+              <a:t> </a:t>
+            </a:r>
+            <a:r>
+              <a:rPr lang="en-US" sz="1200" dirty="0" err="1">
+                <a:solidFill>
+                  <a:srgbClr val="FF0000"/>
+                </a:solidFill>
+                <a:latin typeface="Arial" panose="020B0604020202020204" pitchFamily="34" charset="0"/>
+                <a:cs typeface="Arial" panose="020B0604020202020204" pitchFamily="34" charset="0"/>
+              </a:rPr>
+              <a:t>provocando</a:t>
+            </a:r>
+            <a:r>
+              <a:rPr lang="en-US" sz="1200" dirty="0">
+                <a:solidFill>
+                  <a:srgbClr val="FF0000"/>
+                </a:solidFill>
+                <a:latin typeface="Arial" panose="020B0604020202020204" pitchFamily="34" charset="0"/>
+                <a:cs typeface="Arial" panose="020B0604020202020204" pitchFamily="34" charset="0"/>
+              </a:rPr>
+              <a:t> </a:t>
+            </a:r>
+            <a:r>
+              <a:rPr lang="en-US" sz="1200" dirty="0" err="1">
+                <a:solidFill>
+                  <a:srgbClr val="FF0000"/>
+                </a:solidFill>
+                <a:latin typeface="Arial" panose="020B0604020202020204" pitchFamily="34" charset="0"/>
+                <a:cs typeface="Arial" panose="020B0604020202020204" pitchFamily="34" charset="0"/>
+              </a:rPr>
+              <a:t>el</a:t>
+            </a:r>
+            <a:r>
+              <a:rPr lang="en-US" sz="1200" dirty="0">
+                <a:solidFill>
+                  <a:srgbClr val="FF0000"/>
+                </a:solidFill>
+                <a:latin typeface="Arial" panose="020B0604020202020204" pitchFamily="34" charset="0"/>
+                <a:cs typeface="Arial" panose="020B0604020202020204" pitchFamily="34" charset="0"/>
+              </a:rPr>
+              <a:t> </a:t>
+            </a:r>
+            <a:r>
+              <a:rPr lang="en-US" sz="1200" dirty="0" err="1">
+                <a:solidFill>
+                  <a:srgbClr val="FF0000"/>
+                </a:solidFill>
+                <a:latin typeface="Arial" panose="020B0604020202020204" pitchFamily="34" charset="0"/>
+                <a:cs typeface="Arial" panose="020B0604020202020204" pitchFamily="34" charset="0"/>
+              </a:rPr>
+              <a:t>efecto</a:t>
+            </a:r>
+            <a:r>
+              <a:rPr lang="en-US" sz="1200" dirty="0">
+                <a:solidFill>
+                  <a:srgbClr val="FF0000"/>
+                </a:solidFill>
+                <a:latin typeface="Arial" panose="020B0604020202020204" pitchFamily="34" charset="0"/>
+                <a:cs typeface="Arial" panose="020B0604020202020204" pitchFamily="34" charset="0"/>
+              </a:rPr>
+              <a:t> </a:t>
+            </a:r>
+            <a:r>
+              <a:rPr lang="en-US" sz="1200" dirty="0" err="1">
+                <a:solidFill>
+                  <a:srgbClr val="FF0000"/>
+                </a:solidFill>
+                <a:latin typeface="Arial" panose="020B0604020202020204" pitchFamily="34" charset="0"/>
+                <a:cs typeface="Arial" panose="020B0604020202020204" pitchFamily="34" charset="0"/>
+              </a:rPr>
+              <a:t>autoimagen</a:t>
+            </a:r>
+            <a:r>
+              <a:rPr lang="en-US" sz="1200" dirty="0">
+                <a:solidFill>
+                  <a:srgbClr val="FF0000"/>
+                </a:solidFill>
+                <a:latin typeface="Arial" panose="020B0604020202020204" pitchFamily="34" charset="0"/>
+                <a:cs typeface="Arial" panose="020B0604020202020204" pitchFamily="34" charset="0"/>
+              </a:rPr>
+              <a:t>, </a:t>
+            </a:r>
+            <a:r>
+              <a:rPr lang="en-US" sz="1200" dirty="0" err="1">
+                <a:solidFill>
+                  <a:srgbClr val="FF0000"/>
+                </a:solidFill>
+                <a:latin typeface="Arial" panose="020B0604020202020204" pitchFamily="34" charset="0"/>
+                <a:cs typeface="Arial" panose="020B0604020202020204" pitchFamily="34" charset="0"/>
+              </a:rPr>
+              <a:t>replicando</a:t>
+            </a:r>
+            <a:r>
+              <a:rPr lang="en-US" sz="1200" dirty="0">
+                <a:solidFill>
+                  <a:srgbClr val="FF0000"/>
+                </a:solidFill>
+                <a:latin typeface="Arial" panose="020B0604020202020204" pitchFamily="34" charset="0"/>
+                <a:cs typeface="Arial" panose="020B0604020202020204" pitchFamily="34" charset="0"/>
+              </a:rPr>
+              <a:t> a </a:t>
+            </a:r>
+            <a:r>
+              <a:rPr lang="en-US" sz="1200" dirty="0" err="1">
+                <a:solidFill>
+                  <a:srgbClr val="FF0000"/>
+                </a:solidFill>
+                <a:latin typeface="Arial" panose="020B0604020202020204" pitchFamily="34" charset="0"/>
+                <a:cs typeface="Arial" panose="020B0604020202020204" pitchFamily="34" charset="0"/>
+              </a:rPr>
+              <a:t>cierta</a:t>
+            </a:r>
+            <a:r>
+              <a:rPr lang="en-US" sz="1200" dirty="0">
+                <a:solidFill>
+                  <a:srgbClr val="FF0000"/>
+                </a:solidFill>
+                <a:latin typeface="Arial" panose="020B0604020202020204" pitchFamily="34" charset="0"/>
+                <a:cs typeface="Arial" panose="020B0604020202020204" pitchFamily="34" charset="0"/>
+              </a:rPr>
+              <a:t> </a:t>
+            </a:r>
+            <a:r>
+              <a:rPr lang="en-US" sz="1200" dirty="0" err="1">
+                <a:solidFill>
+                  <a:srgbClr val="FF0000"/>
+                </a:solidFill>
+                <a:latin typeface="Arial" panose="020B0604020202020204" pitchFamily="34" charset="0"/>
+                <a:cs typeface="Arial" panose="020B0604020202020204" pitchFamily="34" charset="0"/>
+              </a:rPr>
+              <a:t>distancia</a:t>
+            </a:r>
+            <a:r>
+              <a:rPr lang="en-US" sz="1200" dirty="0">
+                <a:solidFill>
+                  <a:srgbClr val="FF0000"/>
+                </a:solidFill>
+                <a:latin typeface="Arial" panose="020B0604020202020204" pitchFamily="34" charset="0"/>
+                <a:cs typeface="Arial" panose="020B0604020202020204" pitchFamily="34" charset="0"/>
+              </a:rPr>
+              <a:t> la </a:t>
+            </a:r>
+            <a:r>
+              <a:rPr lang="en-US" sz="1200" dirty="0" err="1">
+                <a:solidFill>
+                  <a:srgbClr val="FF0000"/>
+                </a:solidFill>
+                <a:latin typeface="Arial" panose="020B0604020202020204" pitchFamily="34" charset="0"/>
+                <a:cs typeface="Arial" panose="020B0604020202020204" pitchFamily="34" charset="0"/>
+              </a:rPr>
+              <a:t>img</a:t>
+            </a:r>
+            <a:r>
+              <a:rPr lang="en-US" sz="1200" dirty="0">
+                <a:solidFill>
+                  <a:srgbClr val="FF0000"/>
+                </a:solidFill>
+                <a:latin typeface="Arial" panose="020B0604020202020204" pitchFamily="34" charset="0"/>
+                <a:cs typeface="Arial" panose="020B0604020202020204" pitchFamily="34" charset="0"/>
+              </a:rPr>
+              <a:t> de la entrada. Para </a:t>
+            </a:r>
+            <a:r>
+              <a:rPr lang="en-US" sz="1200" dirty="0" err="1">
+                <a:solidFill>
+                  <a:srgbClr val="FF0000"/>
+                </a:solidFill>
+                <a:latin typeface="Arial" panose="020B0604020202020204" pitchFamily="34" charset="0"/>
+                <a:cs typeface="Arial" panose="020B0604020202020204" pitchFamily="34" charset="0"/>
+              </a:rPr>
+              <a:t>sacar</a:t>
+            </a:r>
+            <a:r>
+              <a:rPr lang="en-US" sz="1200" dirty="0">
+                <a:solidFill>
+                  <a:srgbClr val="FF0000"/>
+                </a:solidFill>
+                <a:latin typeface="Arial" panose="020B0604020202020204" pitchFamily="34" charset="0"/>
+                <a:cs typeface="Arial" panose="020B0604020202020204" pitchFamily="34" charset="0"/>
+              </a:rPr>
+              <a:t> </a:t>
+            </a:r>
+            <a:r>
+              <a:rPr lang="en-US" sz="1200" dirty="0" err="1">
+                <a:solidFill>
+                  <a:srgbClr val="FF0000"/>
+                </a:solidFill>
+                <a:latin typeface="Arial" panose="020B0604020202020204" pitchFamily="34" charset="0"/>
+                <a:cs typeface="Arial" panose="020B0604020202020204" pitchFamily="34" charset="0"/>
+              </a:rPr>
+              <a:t>esta</a:t>
+            </a:r>
+            <a:r>
+              <a:rPr lang="en-US" sz="1200" dirty="0">
+                <a:solidFill>
+                  <a:srgbClr val="FF0000"/>
+                </a:solidFill>
+                <a:latin typeface="Arial" panose="020B0604020202020204" pitchFamily="34" charset="0"/>
+                <a:cs typeface="Arial" panose="020B0604020202020204" pitchFamily="34" charset="0"/>
+              </a:rPr>
+              <a:t> </a:t>
+            </a:r>
+            <a:r>
+              <a:rPr lang="en-US" sz="1200" dirty="0" err="1">
+                <a:solidFill>
+                  <a:srgbClr val="FF0000"/>
+                </a:solidFill>
+                <a:latin typeface="Arial" panose="020B0604020202020204" pitchFamily="34" charset="0"/>
+                <a:cs typeface="Arial" panose="020B0604020202020204" pitchFamily="34" charset="0"/>
+              </a:rPr>
+              <a:t>distancia</a:t>
+            </a:r>
+            <a:r>
+              <a:rPr lang="en-US" sz="1200" dirty="0">
+                <a:solidFill>
+                  <a:srgbClr val="FF0000"/>
+                </a:solidFill>
+                <a:latin typeface="Arial" panose="020B0604020202020204" pitchFamily="34" charset="0"/>
+                <a:cs typeface="Arial" panose="020B0604020202020204" pitchFamily="34" charset="0"/>
+              </a:rPr>
+              <a:t> </a:t>
+            </a:r>
+            <a:r>
+              <a:rPr lang="en-US" sz="1200" dirty="0" err="1">
+                <a:solidFill>
+                  <a:srgbClr val="FF0000"/>
+                </a:solidFill>
+                <a:latin typeface="Arial" panose="020B0604020202020204" pitchFamily="34" charset="0"/>
+                <a:cs typeface="Arial" panose="020B0604020202020204" pitchFamily="34" charset="0"/>
+              </a:rPr>
+              <a:t>el</a:t>
+            </a:r>
+            <a:r>
+              <a:rPr lang="en-US" sz="1200" dirty="0">
+                <a:solidFill>
+                  <a:srgbClr val="FF0000"/>
+                </a:solidFill>
+                <a:latin typeface="Arial" panose="020B0604020202020204" pitchFamily="34" charset="0"/>
+                <a:cs typeface="Arial" panose="020B0604020202020204" pitchFamily="34" charset="0"/>
+              </a:rPr>
+              <a:t> parametron clave es la longitude de batido, para </a:t>
+            </a:r>
+            <a:r>
+              <a:rPr lang="en-US" sz="1200" dirty="0" err="1">
+                <a:solidFill>
+                  <a:srgbClr val="FF0000"/>
+                </a:solidFill>
+                <a:latin typeface="Arial" panose="020B0604020202020204" pitchFamily="34" charset="0"/>
+                <a:cs typeface="Arial" panose="020B0604020202020204" pitchFamily="34" charset="0"/>
+              </a:rPr>
+              <a:t>ello</a:t>
+            </a:r>
+            <a:r>
+              <a:rPr lang="en-US" sz="1200" dirty="0">
+                <a:solidFill>
+                  <a:srgbClr val="FF0000"/>
+                </a:solidFill>
+                <a:latin typeface="Arial" panose="020B0604020202020204" pitchFamily="34" charset="0"/>
+                <a:cs typeface="Arial" panose="020B0604020202020204" pitchFamily="34" charset="0"/>
+              </a:rPr>
+              <a:t> se </a:t>
+            </a:r>
+            <a:r>
+              <a:rPr lang="en-US" sz="1200" dirty="0" err="1">
+                <a:solidFill>
+                  <a:srgbClr val="FF0000"/>
+                </a:solidFill>
+                <a:latin typeface="Arial" panose="020B0604020202020204" pitchFamily="34" charset="0"/>
+                <a:cs typeface="Arial" panose="020B0604020202020204" pitchFamily="34" charset="0"/>
+              </a:rPr>
+              <a:t>calculan</a:t>
+            </a:r>
+            <a:r>
+              <a:rPr lang="en-US" sz="1200" dirty="0">
+                <a:solidFill>
+                  <a:srgbClr val="FF0000"/>
+                </a:solidFill>
+                <a:latin typeface="Arial" panose="020B0604020202020204" pitchFamily="34" charset="0"/>
+                <a:cs typeface="Arial" panose="020B0604020202020204" pitchFamily="34" charset="0"/>
+              </a:rPr>
+              <a:t> y </a:t>
+            </a:r>
+            <a:r>
+              <a:rPr lang="en-US" sz="1200" dirty="0" err="1">
+                <a:solidFill>
+                  <a:srgbClr val="FF0000"/>
+                </a:solidFill>
+                <a:latin typeface="Arial" panose="020B0604020202020204" pitchFamily="34" charset="0"/>
+                <a:cs typeface="Arial" panose="020B0604020202020204" pitchFamily="34" charset="0"/>
+              </a:rPr>
+              <a:t>clasifican</a:t>
+            </a:r>
+            <a:r>
+              <a:rPr lang="en-US" sz="1200" dirty="0">
+                <a:solidFill>
+                  <a:srgbClr val="FF0000"/>
+                </a:solidFill>
+                <a:latin typeface="Arial" panose="020B0604020202020204" pitchFamily="34" charset="0"/>
+                <a:cs typeface="Arial" panose="020B0604020202020204" pitchFamily="34" charset="0"/>
+              </a:rPr>
+              <a:t> </a:t>
+            </a:r>
+            <a:r>
+              <a:rPr lang="en-US" sz="1200" dirty="0" err="1">
+                <a:solidFill>
+                  <a:srgbClr val="FF0000"/>
+                </a:solidFill>
+                <a:latin typeface="Arial" panose="020B0604020202020204" pitchFamily="34" charset="0"/>
+                <a:cs typeface="Arial" panose="020B0604020202020204" pitchFamily="34" charset="0"/>
+              </a:rPr>
+              <a:t>los</a:t>
+            </a:r>
+            <a:r>
+              <a:rPr lang="en-US" sz="1200" dirty="0">
+                <a:solidFill>
+                  <a:srgbClr val="FF0000"/>
+                </a:solidFill>
+                <a:latin typeface="Arial" panose="020B0604020202020204" pitchFamily="34" charset="0"/>
+                <a:cs typeface="Arial" panose="020B0604020202020204" pitchFamily="34" charset="0"/>
+              </a:rPr>
+              <a:t> </a:t>
+            </a:r>
+            <a:r>
+              <a:rPr lang="en-US" sz="1200" dirty="0" err="1">
+                <a:solidFill>
+                  <a:srgbClr val="FF0000"/>
+                </a:solidFill>
+                <a:latin typeface="Arial" panose="020B0604020202020204" pitchFamily="34" charset="0"/>
+                <a:cs typeface="Arial" panose="020B0604020202020204" pitchFamily="34" charset="0"/>
+              </a:rPr>
+              <a:t>modos</a:t>
+            </a:r>
+            <a:r>
+              <a:rPr lang="en-US" sz="1200" dirty="0">
+                <a:solidFill>
+                  <a:srgbClr val="FF0000"/>
+                </a:solidFill>
+                <a:latin typeface="Arial" panose="020B0604020202020204" pitchFamily="34" charset="0"/>
+                <a:cs typeface="Arial" panose="020B0604020202020204" pitchFamily="34" charset="0"/>
+              </a:rPr>
+              <a:t> y se </a:t>
+            </a:r>
+            <a:r>
+              <a:rPr lang="en-US" sz="1200" dirty="0" err="1">
+                <a:solidFill>
+                  <a:srgbClr val="FF0000"/>
+                </a:solidFill>
+                <a:latin typeface="Arial" panose="020B0604020202020204" pitchFamily="34" charset="0"/>
+                <a:cs typeface="Arial" panose="020B0604020202020204" pitchFamily="34" charset="0"/>
+              </a:rPr>
+              <a:t>calcula</a:t>
+            </a:r>
+            <a:r>
+              <a:rPr lang="en-US" sz="1200" dirty="0">
+                <a:solidFill>
+                  <a:srgbClr val="FF0000"/>
+                </a:solidFill>
+                <a:latin typeface="Arial" panose="020B0604020202020204" pitchFamily="34" charset="0"/>
+                <a:cs typeface="Arial" panose="020B0604020202020204" pitchFamily="34" charset="0"/>
+              </a:rPr>
+              <a:t> la </a:t>
+            </a:r>
+            <a:r>
+              <a:rPr lang="en-US" sz="1200" dirty="0" err="1">
+                <a:solidFill>
+                  <a:srgbClr val="FF0000"/>
+                </a:solidFill>
+                <a:latin typeface="Arial" panose="020B0604020202020204" pitchFamily="34" charset="0"/>
+                <a:cs typeface="Arial" panose="020B0604020202020204" pitchFamily="34" charset="0"/>
+              </a:rPr>
+              <a:t>Lpi</a:t>
+            </a:r>
+            <a:r>
+              <a:rPr lang="en-US" sz="1200" dirty="0">
+                <a:solidFill>
+                  <a:srgbClr val="FF0000"/>
+                </a:solidFill>
+                <a:latin typeface="Arial" panose="020B0604020202020204" pitchFamily="34" charset="0"/>
+                <a:cs typeface="Arial" panose="020B0604020202020204" pitchFamily="34" charset="0"/>
+              </a:rPr>
+              <a:t> de </a:t>
+            </a:r>
+          </a:p>
+          <a:p>
+            <a:pPr marL="228600" indent="-228600" algn="just">
+              <a:buAutoNum type="arabicPeriod"/>
+            </a:pPr>
+            <a:r>
+              <a:rPr lang="en-US" sz="1200" dirty="0">
+                <a:solidFill>
+                  <a:srgbClr val="FF0000"/>
+                </a:solidFill>
+                <a:latin typeface="Arial" panose="020B0604020202020204" pitchFamily="34" charset="0"/>
+                <a:cs typeface="Arial" panose="020B0604020202020204" pitchFamily="34" charset="0"/>
+              </a:rPr>
+              <a:t>definer/similar </a:t>
+            </a:r>
+            <a:r>
+              <a:rPr lang="en-US" sz="1200" dirty="0" err="1">
+                <a:solidFill>
+                  <a:srgbClr val="FF0000"/>
+                </a:solidFill>
+                <a:latin typeface="Arial" panose="020B0604020202020204" pitchFamily="34" charset="0"/>
+                <a:cs typeface="Arial" panose="020B0604020202020204" pitchFamily="34" charset="0"/>
+              </a:rPr>
+              <a:t>seccion</a:t>
+            </a:r>
+            <a:r>
+              <a:rPr lang="en-US" sz="1200" dirty="0">
+                <a:solidFill>
+                  <a:srgbClr val="FF0000"/>
+                </a:solidFill>
+                <a:latin typeface="Arial" panose="020B0604020202020204" pitchFamily="34" charset="0"/>
+                <a:cs typeface="Arial" panose="020B0604020202020204" pitchFamily="34" charset="0"/>
+              </a:rPr>
+              <a:t> transversal</a:t>
+            </a:r>
+          </a:p>
+          <a:p>
+            <a:pPr marL="228600" indent="-228600" algn="just">
+              <a:buAutoNum type="arabicPeriod"/>
+            </a:pPr>
+            <a:r>
+              <a:rPr lang="en-US" sz="1200" dirty="0" err="1">
+                <a:solidFill>
+                  <a:srgbClr val="FF0000"/>
+                </a:solidFill>
+                <a:latin typeface="Arial" panose="020B0604020202020204" pitchFamily="34" charset="0"/>
+                <a:cs typeface="Arial" panose="020B0604020202020204" pitchFamily="34" charset="0"/>
+              </a:rPr>
+              <a:t>Calcular</a:t>
+            </a:r>
+            <a:r>
+              <a:rPr lang="en-US" sz="1200" dirty="0">
+                <a:solidFill>
+                  <a:srgbClr val="FF0000"/>
+                </a:solidFill>
+                <a:latin typeface="Arial" panose="020B0604020202020204" pitchFamily="34" charset="0"/>
+                <a:cs typeface="Arial" panose="020B0604020202020204" pitchFamily="34" charset="0"/>
+              </a:rPr>
+              <a:t> </a:t>
+            </a:r>
+            <a:r>
+              <a:rPr lang="en-US" sz="1200" dirty="0" err="1">
+                <a:solidFill>
+                  <a:srgbClr val="FF0000"/>
+                </a:solidFill>
+                <a:latin typeface="Arial" panose="020B0604020202020204" pitchFamily="34" charset="0"/>
+                <a:cs typeface="Arial" panose="020B0604020202020204" pitchFamily="34" charset="0"/>
+              </a:rPr>
+              <a:t>modos</a:t>
+            </a:r>
             <a:endParaRPr lang="en-US" sz="1200" dirty="0">
+              <a:solidFill>
+                <a:srgbClr val="FF0000"/>
+              </a:solidFill>
               <a:latin typeface="Arial" panose="020B0604020202020204" pitchFamily="34" charset="0"/>
               <a:cs typeface="Arial" panose="020B0604020202020204" pitchFamily="34" charset="0"/>
             </a:endParaRPr>
           </a:p>
           <a:p>
-            <a:pPr algn="just"/>
+            <a:pPr marL="228600" indent="-228600" algn="just">
+              <a:buAutoNum type="arabicPeriod"/>
+            </a:pPr>
+            <a:r>
+              <a:rPr lang="en-US" sz="1200" dirty="0" err="1">
+                <a:solidFill>
+                  <a:srgbClr val="FF0000"/>
+                </a:solidFill>
+                <a:latin typeface="Arial" panose="020B0604020202020204" pitchFamily="34" charset="0"/>
+                <a:cs typeface="Arial" panose="020B0604020202020204" pitchFamily="34" charset="0"/>
+              </a:rPr>
+              <a:t>Clasificar</a:t>
+            </a:r>
+            <a:r>
+              <a:rPr lang="en-US" sz="1200" dirty="0">
+                <a:solidFill>
+                  <a:srgbClr val="FF0000"/>
+                </a:solidFill>
+                <a:latin typeface="Arial" panose="020B0604020202020204" pitchFamily="34" charset="0"/>
+                <a:cs typeface="Arial" panose="020B0604020202020204" pitchFamily="34" charset="0"/>
+              </a:rPr>
+              <a:t> </a:t>
+            </a:r>
+            <a:r>
+              <a:rPr lang="en-US" sz="1200" dirty="0" err="1">
+                <a:solidFill>
+                  <a:srgbClr val="FF0000"/>
+                </a:solidFill>
+                <a:latin typeface="Arial" panose="020B0604020202020204" pitchFamily="34" charset="0"/>
+                <a:cs typeface="Arial" panose="020B0604020202020204" pitchFamily="34" charset="0"/>
+              </a:rPr>
+              <a:t>polarizacion</a:t>
+            </a:r>
             <a:endParaRPr lang="en-US" sz="1200" dirty="0">
+              <a:solidFill>
+                <a:srgbClr val="FF0000"/>
+              </a:solidFill>
               <a:latin typeface="Arial" panose="020B0604020202020204" pitchFamily="34" charset="0"/>
               <a:cs typeface="Arial" panose="020B0604020202020204" pitchFamily="34" charset="0"/>
+            </a:endParaRPr>
+          </a:p>
+          <a:p>
+            <a:pPr marL="228600" indent="-228600" algn="just">
+              <a:buAutoNum type="arabicPeriod"/>
+            </a:pPr>
+            <a:r>
+              <a:rPr lang="en-US" sz="1200" dirty="0" err="1">
+                <a:solidFill>
+                  <a:srgbClr val="FF0000"/>
+                </a:solidFill>
+                <a:latin typeface="Arial" panose="020B0604020202020204" pitchFamily="34" charset="0"/>
+                <a:cs typeface="Arial" panose="020B0604020202020204" pitchFamily="34" charset="0"/>
+              </a:rPr>
+              <a:t>Definir</a:t>
+            </a:r>
+            <a:r>
+              <a:rPr lang="en-US" sz="1200" dirty="0">
+                <a:solidFill>
+                  <a:srgbClr val="FF0000"/>
+                </a:solidFill>
+                <a:latin typeface="Arial" panose="020B0604020202020204" pitchFamily="34" charset="0"/>
+                <a:cs typeface="Arial" panose="020B0604020202020204" pitchFamily="34" charset="0"/>
+              </a:rPr>
+              <a:t> </a:t>
+            </a:r>
+            <a:r>
+              <a:rPr lang="en-US" sz="1200" dirty="0" err="1">
+                <a:solidFill>
+                  <a:srgbClr val="FF0000"/>
+                </a:solidFill>
+                <a:latin typeface="Arial" panose="020B0604020202020204" pitchFamily="34" charset="0"/>
+                <a:cs typeface="Arial" panose="020B0604020202020204" pitchFamily="34" charset="0"/>
+              </a:rPr>
+              <a:t>Lpi</a:t>
+            </a:r>
+            <a:endParaRPr lang="en-US" sz="1200" dirty="0">
+              <a:solidFill>
+                <a:srgbClr val="FF0000"/>
+              </a:solidFill>
+              <a:latin typeface="Arial" panose="020B0604020202020204" pitchFamily="34" charset="0"/>
+              <a:cs typeface="Arial" panose="020B0604020202020204" pitchFamily="34" charset="0"/>
+            </a:endParaRPr>
+          </a:p>
+          <a:p>
+            <a:endParaRPr lang="es-ES" sz="1200" dirty="0">
+              <a:solidFill>
+                <a:srgbClr val="FF0000"/>
+              </a:solidFill>
             </a:endParaRPr>
           </a:p>
         </p:txBody>
@@ -5146,6 +6095,731 @@
 </file>
 
 <file path=ppt/slides/slide4.xml><?xml version="1.0" encoding="utf-8"?>
+<p:sld xmlns:a="http://schemas.openxmlformats.org/drawingml/2006/main" xmlns:r="http://schemas.openxmlformats.org/officeDocument/2006/relationships" xmlns:p="http://schemas.openxmlformats.org/presentationml/2006/main">
+  <p:cSld>
+    <p:spTree>
+      <p:nvGrpSpPr>
+        <p:cNvPr id="1" name=""/>
+        <p:cNvGrpSpPr/>
+        <p:nvPr/>
+      </p:nvGrpSpPr>
+      <p:grpSpPr>
+        <a:xfrm>
+          <a:off x="0" y="0"/>
+          <a:ext cx="0" cy="0"/>
+          <a:chOff x="0" y="0"/>
+          <a:chExt cx="0" cy="0"/>
+        </a:xfrm>
+      </p:grpSpPr>
+      <p:sp>
+        <p:nvSpPr>
+          <p:cNvPr id="2" name="Título 1">
+            <a:extLst>
+              <a:ext uri="{FF2B5EF4-FFF2-40B4-BE49-F238E27FC236}">
+                <a16:creationId xmlns:a16="http://schemas.microsoft.com/office/drawing/2014/main" id="{79B249B9-C8E6-3DA9-A048-F972AA9F248B}"/>
+              </a:ext>
+            </a:extLst>
+          </p:cNvPr>
+          <p:cNvSpPr>
+            <a:spLocks noGrp="1"/>
+          </p:cNvSpPr>
+          <p:nvPr>
+            <p:ph type="title"/>
+          </p:nvPr>
+        </p:nvSpPr>
+        <p:spPr/>
+        <p:txBody>
+          <a:bodyPr/>
+          <a:lstStyle/>
+          <a:p>
+            <a:r>
+              <a:rPr lang="es-ES" dirty="0"/>
+              <a:t>Comentarios</a:t>
+            </a:r>
+          </a:p>
+        </p:txBody>
+      </p:sp>
+      <p:sp>
+        <p:nvSpPr>
+          <p:cNvPr id="3" name="Marcador de texto 2">
+            <a:extLst>
+              <a:ext uri="{FF2B5EF4-FFF2-40B4-BE49-F238E27FC236}">
+                <a16:creationId xmlns:a16="http://schemas.microsoft.com/office/drawing/2014/main" id="{5AEBCB4F-5FC4-E118-011C-D4EC5DA4B8A3}"/>
+              </a:ext>
+            </a:extLst>
+          </p:cNvPr>
+          <p:cNvSpPr>
+            <a:spLocks noGrp="1"/>
+          </p:cNvSpPr>
+          <p:nvPr>
+            <p:ph type="body" idx="1"/>
+          </p:nvPr>
+        </p:nvSpPr>
+        <p:spPr>
+          <a:xfrm>
+            <a:off x="590550" y="685800"/>
+            <a:ext cx="4754899" cy="533400"/>
+          </a:xfrm>
+        </p:spPr>
+        <p:txBody>
+          <a:bodyPr/>
+          <a:lstStyle/>
+          <a:p>
+            <a:r>
+              <a:rPr lang="es-ES" sz="1400" dirty="0"/>
+              <a:t>En este acoplador direccional se propagan 4 modos. Los modos 0 y 1 son </a:t>
+            </a:r>
+            <a:r>
+              <a:rPr lang="es-ES" sz="1400" dirty="0" err="1"/>
+              <a:t>quasi</a:t>
+            </a:r>
+            <a:r>
+              <a:rPr lang="es-ES" sz="1400" dirty="0"/>
+              <a:t> TE y los modos 2 y 3 son </a:t>
+            </a:r>
+            <a:r>
+              <a:rPr lang="es-ES" sz="1400" dirty="0" err="1"/>
+              <a:t>quasi</a:t>
+            </a:r>
+            <a:r>
+              <a:rPr lang="es-ES" sz="1400" dirty="0"/>
+              <a:t> TM.</a:t>
+            </a:r>
+          </a:p>
+        </p:txBody>
+      </p:sp>
+      <p:sp>
+        <p:nvSpPr>
+          <p:cNvPr id="4" name="Marcador de pie de página 3">
+            <a:extLst>
+              <a:ext uri="{FF2B5EF4-FFF2-40B4-BE49-F238E27FC236}">
+                <a16:creationId xmlns:a16="http://schemas.microsoft.com/office/drawing/2014/main" id="{28336144-52DC-BDA9-B02D-858A6110F885}"/>
+              </a:ext>
+            </a:extLst>
+          </p:cNvPr>
+          <p:cNvSpPr>
+            <a:spLocks noGrp="1"/>
+          </p:cNvSpPr>
+          <p:nvPr>
+            <p:ph type="ftr" sz="quarter" idx="5"/>
+          </p:nvPr>
+        </p:nvSpPr>
+        <p:spPr/>
+        <p:txBody>
+          <a:bodyPr/>
+          <a:lstStyle/>
+          <a:p>
+            <a:pPr marL="12700">
+              <a:spcBef>
+                <a:spcPts val="15"/>
+              </a:spcBef>
+            </a:pPr>
+            <a:r>
+              <a:rPr lang="es-ES" spc="-5"/>
+              <a:t>LAB 0.2. COUPLERS</a:t>
+            </a:r>
+            <a:endParaRPr lang="es-ES" spc="-5" dirty="0"/>
+          </a:p>
+        </p:txBody>
+      </p:sp>
+      <p:sp>
+        <p:nvSpPr>
+          <p:cNvPr id="5" name="Marcador de número de diapositiva 4">
+            <a:extLst>
+              <a:ext uri="{FF2B5EF4-FFF2-40B4-BE49-F238E27FC236}">
+                <a16:creationId xmlns:a16="http://schemas.microsoft.com/office/drawing/2014/main" id="{0A2E171D-AEFC-0C5A-9E9E-50D56858C5A9}"/>
+              </a:ext>
+            </a:extLst>
+          </p:cNvPr>
+          <p:cNvSpPr>
+            <a:spLocks noGrp="1"/>
+          </p:cNvSpPr>
+          <p:nvPr>
+            <p:ph type="sldNum" sz="quarter" idx="7"/>
+          </p:nvPr>
+        </p:nvSpPr>
+        <p:spPr/>
+        <p:txBody>
+          <a:bodyPr/>
+          <a:lstStyle/>
+          <a:p>
+            <a:fld id="{B6F15528-21DE-4FAA-801E-634DDDAF4B2B}" type="slidenum">
+              <a:rPr lang="es-ES" smtClean="0"/>
+              <a:t>4</a:t>
+            </a:fld>
+            <a:endParaRPr lang="es-ES"/>
+          </a:p>
+        </p:txBody>
+      </p:sp>
+      <p:pic>
+        <p:nvPicPr>
+          <p:cNvPr id="9" name="Imagen 8" descr="Texto&#10;&#10;El contenido generado por IA puede ser incorrecto.">
+            <a:extLst>
+              <a:ext uri="{FF2B5EF4-FFF2-40B4-BE49-F238E27FC236}">
+                <a16:creationId xmlns:a16="http://schemas.microsoft.com/office/drawing/2014/main" id="{8150B5A6-4637-12FA-075A-97026B32B8E6}"/>
+              </a:ext>
+            </a:extLst>
+          </p:cNvPr>
+          <p:cNvPicPr>
+            <a:picLocks noChangeAspect="1"/>
+          </p:cNvPicPr>
+          <p:nvPr/>
+        </p:nvPicPr>
+        <p:blipFill>
+          <a:blip r:embed="rId2"/>
+          <a:stretch>
+            <a:fillRect/>
+          </a:stretch>
+        </p:blipFill>
+        <p:spPr>
+          <a:xfrm>
+            <a:off x="641091" y="1295400"/>
+            <a:ext cx="4704358" cy="2376681"/>
+          </a:xfrm>
+          <a:prstGeom prst="rect">
+            <a:avLst/>
+          </a:prstGeom>
+        </p:spPr>
+      </p:pic>
+      <p:pic>
+        <p:nvPicPr>
+          <p:cNvPr id="11" name="Imagen 10" descr="Una pantalla de computadora&#10;&#10;El contenido generado por IA puede ser incorrecto.">
+            <a:extLst>
+              <a:ext uri="{FF2B5EF4-FFF2-40B4-BE49-F238E27FC236}">
+                <a16:creationId xmlns:a16="http://schemas.microsoft.com/office/drawing/2014/main" id="{0E15A150-145C-2AA5-B124-A01A92BA4584}"/>
+              </a:ext>
+            </a:extLst>
+          </p:cNvPr>
+          <p:cNvPicPr>
+            <a:picLocks noChangeAspect="1"/>
+          </p:cNvPicPr>
+          <p:nvPr/>
+        </p:nvPicPr>
+        <p:blipFill>
+          <a:blip r:embed="rId3"/>
+          <a:stretch>
+            <a:fillRect/>
+          </a:stretch>
+        </p:blipFill>
+        <p:spPr>
+          <a:xfrm>
+            <a:off x="5345449" y="1295400"/>
+            <a:ext cx="3450897" cy="1166569"/>
+          </a:xfrm>
+          <a:prstGeom prst="rect">
+            <a:avLst/>
+          </a:prstGeom>
+        </p:spPr>
+      </p:pic>
+      <p:pic>
+        <p:nvPicPr>
+          <p:cNvPr id="13" name="Imagen 12" descr="Imagen que contiene Interfaz de usuario gráfica&#10;&#10;El contenido generado por IA puede ser incorrecto.">
+            <a:extLst>
+              <a:ext uri="{FF2B5EF4-FFF2-40B4-BE49-F238E27FC236}">
+                <a16:creationId xmlns:a16="http://schemas.microsoft.com/office/drawing/2014/main" id="{5A8C2911-C657-D316-571A-8445C888D6C1}"/>
+              </a:ext>
+            </a:extLst>
+          </p:cNvPr>
+          <p:cNvPicPr>
+            <a:picLocks noChangeAspect="1"/>
+          </p:cNvPicPr>
+          <p:nvPr/>
+        </p:nvPicPr>
+        <p:blipFill>
+          <a:blip r:embed="rId4"/>
+          <a:stretch>
+            <a:fillRect/>
+          </a:stretch>
+        </p:blipFill>
+        <p:spPr>
+          <a:xfrm>
+            <a:off x="8884113" y="1351620"/>
+            <a:ext cx="3262789" cy="1110349"/>
+          </a:xfrm>
+          <a:prstGeom prst="rect">
+            <a:avLst/>
+          </a:prstGeom>
+        </p:spPr>
+      </p:pic>
+      <p:pic>
+        <p:nvPicPr>
+          <p:cNvPr id="15" name="Imagen 14" descr="Captura de pantalla de computadora&#10;&#10;El contenido generado por IA puede ser incorrecto.">
+            <a:extLst>
+              <a:ext uri="{FF2B5EF4-FFF2-40B4-BE49-F238E27FC236}">
+                <a16:creationId xmlns:a16="http://schemas.microsoft.com/office/drawing/2014/main" id="{DAB32154-2285-85CE-0CE5-949137987993}"/>
+              </a:ext>
+            </a:extLst>
+          </p:cNvPr>
+          <p:cNvPicPr>
+            <a:picLocks noChangeAspect="1"/>
+          </p:cNvPicPr>
+          <p:nvPr/>
+        </p:nvPicPr>
+        <p:blipFill>
+          <a:blip r:embed="rId5"/>
+          <a:stretch>
+            <a:fillRect/>
+          </a:stretch>
+        </p:blipFill>
+        <p:spPr>
+          <a:xfrm>
+            <a:off x="5330324" y="2587633"/>
+            <a:ext cx="3577116" cy="1179105"/>
+          </a:xfrm>
+          <a:prstGeom prst="rect">
+            <a:avLst/>
+          </a:prstGeom>
+        </p:spPr>
+      </p:pic>
+      <p:pic>
+        <p:nvPicPr>
+          <p:cNvPr id="17" name="Imagen 16" descr="Imagen que contiene Diagrama&#10;&#10;El contenido generado por IA puede ser incorrecto.">
+            <a:extLst>
+              <a:ext uri="{FF2B5EF4-FFF2-40B4-BE49-F238E27FC236}">
+                <a16:creationId xmlns:a16="http://schemas.microsoft.com/office/drawing/2014/main" id="{DEE44A1E-EFA1-07BF-9A0A-F085584B92B6}"/>
+              </a:ext>
+            </a:extLst>
+          </p:cNvPr>
+          <p:cNvPicPr>
+            <a:picLocks noChangeAspect="1"/>
+          </p:cNvPicPr>
+          <p:nvPr/>
+        </p:nvPicPr>
+        <p:blipFill>
+          <a:blip r:embed="rId6"/>
+          <a:stretch>
+            <a:fillRect/>
+          </a:stretch>
+        </p:blipFill>
+        <p:spPr>
+          <a:xfrm>
+            <a:off x="8900543" y="2656389"/>
+            <a:ext cx="3249469" cy="1110349"/>
+          </a:xfrm>
+          <a:prstGeom prst="rect">
+            <a:avLst/>
+          </a:prstGeom>
+        </p:spPr>
+      </p:pic>
+      <p:pic>
+        <p:nvPicPr>
+          <p:cNvPr id="18" name="Imagen 17" descr="Imagen que contiene Interfaz de usuario gráfica&#10;&#10;El contenido generado por IA puede ser incorrecto.">
+            <a:extLst>
+              <a:ext uri="{FF2B5EF4-FFF2-40B4-BE49-F238E27FC236}">
+                <a16:creationId xmlns:a16="http://schemas.microsoft.com/office/drawing/2014/main" id="{30760F6D-CB3D-E980-9331-8A24616BD52A}"/>
+              </a:ext>
+            </a:extLst>
+          </p:cNvPr>
+          <p:cNvPicPr>
+            <a:picLocks noChangeAspect="1"/>
+          </p:cNvPicPr>
+          <p:nvPr/>
+        </p:nvPicPr>
+        <p:blipFill>
+          <a:blip r:embed="rId4"/>
+          <a:stretch>
+            <a:fillRect/>
+          </a:stretch>
+        </p:blipFill>
+        <p:spPr>
+          <a:xfrm>
+            <a:off x="8884112" y="1414452"/>
+            <a:ext cx="3262789" cy="1110349"/>
+          </a:xfrm>
+          <a:prstGeom prst="rect">
+            <a:avLst/>
+          </a:prstGeom>
+        </p:spPr>
+      </p:pic>
+      <p:sp>
+        <p:nvSpPr>
+          <p:cNvPr id="21" name="Marcador de texto 2">
+            <a:extLst>
+              <a:ext uri="{FF2B5EF4-FFF2-40B4-BE49-F238E27FC236}">
+                <a16:creationId xmlns:a16="http://schemas.microsoft.com/office/drawing/2014/main" id="{51393840-F160-792C-906D-FFA12C2E9009}"/>
+              </a:ext>
+            </a:extLst>
+          </p:cNvPr>
+          <p:cNvSpPr txBox="1">
+            <a:spLocks/>
+          </p:cNvSpPr>
+          <p:nvPr/>
+        </p:nvSpPr>
+        <p:spPr>
+          <a:xfrm>
+            <a:off x="5595946" y="551743"/>
+            <a:ext cx="6400800" cy="646331"/>
+          </a:xfrm>
+          <a:prstGeom prst="rect">
+            <a:avLst/>
+          </a:prstGeom>
+        </p:spPr>
+        <p:txBody>
+          <a:bodyPr wrap="square" lIns="0" tIns="0" rIns="0" bIns="0">
+            <a:spAutoFit/>
+          </a:bodyPr>
+          <a:lstStyle>
+            <a:lvl1pPr marL="0">
+              <a:defRPr>
+                <a:latin typeface="+mn-lt"/>
+                <a:ea typeface="+mn-ea"/>
+                <a:cs typeface="+mn-cs"/>
+              </a:defRPr>
+            </a:lvl1pPr>
+            <a:lvl2pPr marL="457200">
+              <a:defRPr>
+                <a:latin typeface="+mn-lt"/>
+                <a:ea typeface="+mn-ea"/>
+                <a:cs typeface="+mn-cs"/>
+              </a:defRPr>
+            </a:lvl2pPr>
+            <a:lvl3pPr marL="914400">
+              <a:defRPr>
+                <a:latin typeface="+mn-lt"/>
+                <a:ea typeface="+mn-ea"/>
+                <a:cs typeface="+mn-cs"/>
+              </a:defRPr>
+            </a:lvl3pPr>
+            <a:lvl4pPr marL="1371600">
+              <a:defRPr>
+                <a:latin typeface="+mn-lt"/>
+                <a:ea typeface="+mn-ea"/>
+                <a:cs typeface="+mn-cs"/>
+              </a:defRPr>
+            </a:lvl4pPr>
+            <a:lvl5pPr marL="1828800">
+              <a:defRPr>
+                <a:latin typeface="+mn-lt"/>
+                <a:ea typeface="+mn-ea"/>
+                <a:cs typeface="+mn-cs"/>
+              </a:defRPr>
+            </a:lvl5pPr>
+            <a:lvl6pPr marL="2286000">
+              <a:defRPr>
+                <a:latin typeface="+mn-lt"/>
+                <a:ea typeface="+mn-ea"/>
+                <a:cs typeface="+mn-cs"/>
+              </a:defRPr>
+            </a:lvl6pPr>
+            <a:lvl7pPr marL="2743200">
+              <a:defRPr>
+                <a:latin typeface="+mn-lt"/>
+                <a:ea typeface="+mn-ea"/>
+                <a:cs typeface="+mn-cs"/>
+              </a:defRPr>
+            </a:lvl7pPr>
+            <a:lvl8pPr marL="3200400">
+              <a:defRPr>
+                <a:latin typeface="+mn-lt"/>
+                <a:ea typeface="+mn-ea"/>
+                <a:cs typeface="+mn-cs"/>
+              </a:defRPr>
+            </a:lvl8pPr>
+            <a:lvl9pPr marL="3657600">
+              <a:defRPr>
+                <a:latin typeface="+mn-lt"/>
+                <a:ea typeface="+mn-ea"/>
+                <a:cs typeface="+mn-cs"/>
+              </a:defRPr>
+            </a:lvl9pPr>
+          </a:lstStyle>
+          <a:p>
+            <a:r>
+              <a:rPr lang="es-ES" sz="1400" kern="0" dirty="0">
+                <a:solidFill>
+                  <a:sysClr val="windowText" lastClr="000000"/>
+                </a:solidFill>
+              </a:rPr>
+              <a:t>En cuanto a los </a:t>
+            </a:r>
+            <a:r>
+              <a:rPr lang="es-ES" sz="1400" kern="0" dirty="0" err="1">
+                <a:solidFill>
+                  <a:sysClr val="windowText" lastClr="000000"/>
+                </a:solidFill>
+              </a:rPr>
+              <a:t>plots</a:t>
+            </a:r>
+            <a:r>
+              <a:rPr lang="es-ES" sz="1400" kern="0" dirty="0">
+                <a:solidFill>
+                  <a:sysClr val="windowText" lastClr="000000"/>
+                </a:solidFill>
+              </a:rPr>
+              <a:t>, a parte de identificar el tipo de polarización y corroborar así el calculo y deducción anterior. También se observa que los modos 1 (TE) y 3 (TM) son positivo y negativo. A diferencia de los modos 0 (TE) y 2 (TM) que son positivos.</a:t>
+            </a:r>
+          </a:p>
+        </p:txBody>
+      </p:sp>
+      <mc:AlternateContent xmlns:mc="http://schemas.openxmlformats.org/markup-compatibility/2006">
+        <mc:Choice xmlns:a14="http://schemas.microsoft.com/office/drawing/2010/main" Requires="a14">
+          <p:sp>
+            <p:nvSpPr>
+              <p:cNvPr id="22" name="CuadroTexto 21">
+                <a:extLst>
+                  <a:ext uri="{FF2B5EF4-FFF2-40B4-BE49-F238E27FC236}">
+                    <a16:creationId xmlns:a16="http://schemas.microsoft.com/office/drawing/2014/main" id="{A9C709C2-5647-865D-BD7E-362EAB367863}"/>
+                  </a:ext>
+                </a:extLst>
+              </p:cNvPr>
+              <p:cNvSpPr txBox="1"/>
+              <p:nvPr/>
+            </p:nvSpPr>
+            <p:spPr>
+              <a:xfrm>
+                <a:off x="557893" y="3892402"/>
+                <a:ext cx="10941309" cy="1446550"/>
+              </a:xfrm>
+              <a:prstGeom prst="rect">
+                <a:avLst/>
+              </a:prstGeom>
+              <a:noFill/>
+            </p:spPr>
+            <p:txBody>
+              <a:bodyPr wrap="square" rtlCol="0">
+                <a:spAutoFit/>
+              </a:bodyPr>
+              <a:lstStyle/>
+              <a:p>
+                <a:r>
+                  <a:rPr lang="es-ES" sz="1400" dirty="0"/>
+                  <a:t>Cuando calculamos la longitud de batido, que es la distancia </a:t>
+                </a:r>
+                <a:r>
+                  <a:rPr lang="es-ES" sz="1400" dirty="0" err="1"/>
+                  <a:t>minima</a:t>
+                </a:r>
+                <a:r>
+                  <a:rPr lang="es-ES" sz="1400" dirty="0"/>
+                  <a:t> para transferir la </a:t>
+                </a:r>
+                <a:r>
+                  <a:rPr lang="es-ES" sz="1400" dirty="0" err="1"/>
+                  <a:t>energia</a:t>
+                </a:r>
+                <a:r>
+                  <a:rPr lang="es-ES" sz="1400" dirty="0"/>
+                  <a:t> a la </a:t>
+                </a:r>
+                <a:r>
+                  <a:rPr lang="es-ES" sz="1400" dirty="0" err="1"/>
+                  <a:t>guia</a:t>
+                </a:r>
+                <a:r>
+                  <a:rPr lang="es-ES" sz="1400" dirty="0"/>
+                  <a:t> contraria, la cual depende del gap y de la diferencia de índices. Se observa que tenemos dependencia de la polarización del sistema ya que para los modos TE la </a:t>
+                </a:r>
+                <a14:m>
+                  <m:oMath xmlns:m="http://schemas.openxmlformats.org/officeDocument/2006/math">
+                    <m:sSub>
+                      <m:sSubPr>
+                        <m:ctrlPr>
+                          <a:rPr lang="es-ES" sz="1100" b="1" i="1" smtClean="0">
+                            <a:latin typeface="Cambria Math" panose="02040503050406030204" pitchFamily="18" charset="0"/>
+                          </a:rPr>
+                        </m:ctrlPr>
+                      </m:sSubPr>
+                      <m:e>
+                        <m:r>
+                          <a:rPr lang="es-ES" sz="1100" b="1" i="1" smtClean="0">
+                            <a:latin typeface="Cambria Math" panose="02040503050406030204" pitchFamily="18" charset="0"/>
+                          </a:rPr>
+                          <m:t>𝑳</m:t>
+                        </m:r>
+                      </m:e>
+                      <m:sub>
+                        <m:r>
+                          <a:rPr lang="es-ES" sz="1100" b="1" i="1" smtClean="0">
+                            <a:latin typeface="Cambria Math" panose="02040503050406030204" pitchFamily="18" charset="0"/>
+                            <a:ea typeface="Cambria Math" panose="02040503050406030204" pitchFamily="18" charset="0"/>
+                          </a:rPr>
+                          <m:t>𝝅</m:t>
+                        </m:r>
+                      </m:sub>
+                    </m:sSub>
+                    <m:r>
+                      <a:rPr lang="es-ES" sz="1100" b="1" i="1" smtClean="0">
+                        <a:latin typeface="Cambria Math" panose="02040503050406030204" pitchFamily="18" charset="0"/>
+                      </a:rPr>
+                      <m:t>=</m:t>
+                    </m:r>
+                    <m:r>
+                      <m:rPr>
+                        <m:nor/>
+                      </m:rPr>
+                      <a:rPr lang="es-ES" sz="1400" b="1"/>
+                      <m:t>93.83767536700753</m:t>
+                    </m:r>
+                  </m:oMath>
+                </a14:m>
+                <a:r>
+                  <a:rPr lang="es-ES" sz="1400" dirty="0"/>
+                  <a:t> </a:t>
+                </a:r>
+                <a:r>
+                  <a:rPr lang="es-ES" sz="1400" b="1" dirty="0"/>
+                  <a:t>nm</a:t>
+                </a:r>
+                <a:r>
+                  <a:rPr lang="es-ES" sz="1400" dirty="0"/>
+                  <a:t> y para los modos TM la </a:t>
+                </a:r>
+                <a14:m>
+                  <m:oMath xmlns:m="http://schemas.openxmlformats.org/officeDocument/2006/math">
+                    <m:sSub>
+                      <m:sSubPr>
+                        <m:ctrlPr>
+                          <a:rPr lang="es-ES" sz="1000" b="1" i="1">
+                            <a:latin typeface="Cambria Math" panose="02040503050406030204" pitchFamily="18" charset="0"/>
+                          </a:rPr>
+                        </m:ctrlPr>
+                      </m:sSubPr>
+                      <m:e>
+                        <m:r>
+                          <a:rPr lang="es-ES" sz="1000" b="1" i="1">
+                            <a:latin typeface="Cambria Math" panose="02040503050406030204" pitchFamily="18" charset="0"/>
+                          </a:rPr>
+                          <m:t>𝑳</m:t>
+                        </m:r>
+                      </m:e>
+                      <m:sub>
+                        <m:r>
+                          <a:rPr lang="es-ES" sz="1000" b="1" i="1">
+                            <a:latin typeface="Cambria Math" panose="02040503050406030204" pitchFamily="18" charset="0"/>
+                            <a:ea typeface="Cambria Math" panose="02040503050406030204" pitchFamily="18" charset="0"/>
+                          </a:rPr>
+                          <m:t>𝝅</m:t>
+                        </m:r>
+                      </m:sub>
+                    </m:sSub>
+                    <m:r>
+                      <a:rPr lang="es-ES" sz="1000" b="1" i="1">
+                        <a:latin typeface="Cambria Math" panose="02040503050406030204" pitchFamily="18" charset="0"/>
+                      </a:rPr>
+                      <m:t>=</m:t>
+                    </m:r>
+                    <m:r>
+                      <m:rPr>
+                        <m:nor/>
+                      </m:rPr>
+                      <a:rPr lang="es-ES" sz="1400" b="1"/>
+                      <m:t>52.26022367744142</m:t>
+                    </m:r>
+                    <m:r>
+                      <m:rPr>
+                        <m:nor/>
+                      </m:rPr>
+                      <a:rPr lang="es-ES" sz="1400" b="1" i="0" smtClean="0"/>
+                      <m:t> </m:t>
+                    </m:r>
+                    <m:r>
+                      <m:rPr>
+                        <m:nor/>
+                      </m:rPr>
+                      <a:rPr lang="es-ES" sz="1400" b="1" i="0" smtClean="0"/>
+                      <m:t>nm</m:t>
+                    </m:r>
+                    <m:r>
+                      <m:rPr>
+                        <m:nor/>
+                      </m:rPr>
+                      <a:rPr lang="es-ES" sz="1400" b="1" i="0" smtClean="0"/>
+                      <m:t>.</m:t>
+                    </m:r>
+                  </m:oMath>
+                </a14:m>
+                <a:r>
+                  <a:rPr lang="es-ES" sz="1400" dirty="0"/>
+                  <a:t> Es decir, si se diseña un dispositivo para TE con su respectiva longitud pero erróneamente llevamos una </a:t>
+                </a:r>
+                <a:r>
+                  <a:rPr lang="es-ES" sz="1400" dirty="0" err="1"/>
+                  <a:t>polarizacion</a:t>
+                </a:r>
+                <a:r>
+                  <a:rPr lang="es-ES" sz="1400" dirty="0"/>
+                  <a:t> TM, el resultado no será el esperado.</a:t>
+                </a:r>
+              </a:p>
+              <a:p>
+                <a:r>
+                  <a:rPr lang="es-ES" sz="1400" dirty="0"/>
+                  <a:t>Es mejor hacer el calculo a mano porque GDS da por hecho que el modo 0 es TE y el 1 es TM es </a:t>
+                </a:r>
+                <a:r>
+                  <a:rPr lang="es-ES" sz="1400" dirty="0" err="1"/>
+                  <a:t>asi</a:t>
+                </a:r>
+                <a:r>
+                  <a:rPr lang="es-ES" sz="1400" dirty="0"/>
+                  <a:t> siempre y no es cierto</a:t>
+                </a:r>
+              </a:p>
+              <a:p>
+                <a:endParaRPr lang="es-ES" dirty="0"/>
+              </a:p>
+            </p:txBody>
+          </p:sp>
+        </mc:Choice>
+        <mc:Fallback>
+          <p:sp>
+            <p:nvSpPr>
+              <p:cNvPr id="22" name="CuadroTexto 21">
+                <a:extLst>
+                  <a:ext uri="{FF2B5EF4-FFF2-40B4-BE49-F238E27FC236}">
+                    <a16:creationId xmlns:a16="http://schemas.microsoft.com/office/drawing/2014/main" id="{A9C709C2-5647-865D-BD7E-362EAB367863}"/>
+                  </a:ext>
+                </a:extLst>
+              </p:cNvPr>
+              <p:cNvSpPr txBox="1">
+                <a:spLocks noRot="1" noChangeAspect="1" noMove="1" noResize="1" noEditPoints="1" noAdjustHandles="1" noChangeArrowheads="1" noChangeShapeType="1" noTextEdit="1"/>
+              </p:cNvSpPr>
+              <p:nvPr/>
+            </p:nvSpPr>
+            <p:spPr>
+              <a:xfrm>
+                <a:off x="557893" y="3892402"/>
+                <a:ext cx="10941309" cy="1446550"/>
+              </a:xfrm>
+              <a:prstGeom prst="rect">
+                <a:avLst/>
+              </a:prstGeom>
+              <a:blipFill>
+                <a:blip r:embed="rId7"/>
+                <a:stretch>
+                  <a:fillRect l="-167" t="-844"/>
+                </a:stretch>
+              </a:blipFill>
+            </p:spPr>
+            <p:txBody>
+              <a:bodyPr/>
+              <a:lstStyle/>
+              <a:p>
+                <a:r>
+                  <a:rPr lang="es-ES">
+                    <a:noFill/>
+                  </a:rPr>
+                  <a:t> </a:t>
+                </a:r>
+              </a:p>
+            </p:txBody>
+          </p:sp>
+        </mc:Fallback>
+      </mc:AlternateContent>
+    </p:spTree>
+    <p:extLst>
+      <p:ext uri="{BB962C8B-B14F-4D97-AF65-F5344CB8AC3E}">
+        <p14:creationId xmlns:p14="http://schemas.microsoft.com/office/powerpoint/2010/main" val="521885150"/>
+      </p:ext>
+    </p:extLst>
+  </p:cSld>
+  <p:clrMapOvr>
+    <a:masterClrMapping/>
+  </p:clrMapOvr>
+</p:sld>
+</file>
+
+<file path=ppt/slides/slide5.xml><?xml version="1.0" encoding="utf-8"?>
 <p:sld xmlns:a="http://schemas.openxmlformats.org/drawingml/2006/main" xmlns:r="http://schemas.openxmlformats.org/officeDocument/2006/relationships" xmlns:p="http://schemas.openxmlformats.org/presentationml/2006/main">
   <p:cSld>
     <p:spTree>
@@ -5277,7 +6951,7 @@
           <a:p>
             <a:fld id="{B6F15528-21DE-4FAA-801E-634DDDAF4B2B}" type="slidenum">
               <a:rPr lang="es-ES" smtClean="0"/>
-              <a:t>4</a:t>
+              <a:t>5</a:t>
             </a:fld>
             <a:endParaRPr lang="es-ES"/>
           </a:p>
@@ -5317,8 +6991,8 @@
           </a:p>
         </p:txBody>
       </p:sp>
-      <mc:AlternateContent xmlns:mc="http://schemas.openxmlformats.org/markup-compatibility/2006">
-        <mc:Choice xmlns:a14="http://schemas.microsoft.com/office/drawing/2010/main" Requires="a14">
+      <mc:AlternateContent xmlns:mc="http://schemas.openxmlformats.org/markup-compatibility/2006" xmlns:a14="http://schemas.microsoft.com/office/drawing/2010/main">
+        <mc:Choice Requires="a14">
           <p:sp>
             <p:nvSpPr>
               <p:cNvPr id="4" name="Marcador de texto 2">
@@ -5552,7 +7226,7 @@
             </p:txBody>
           </p:sp>
         </mc:Choice>
-        <mc:Fallback>
+        <mc:Fallback xmlns="">
           <p:sp>
             <p:nvSpPr>
               <p:cNvPr id="4" name="Marcador de texto 2">
@@ -5718,7 +7392,1010 @@
 </p:sld>
 </file>
 
-<file path=ppt/slides/slide5.xml><?xml version="1.0" encoding="utf-8"?>
+<file path=ppt/slides/slide6.xml><?xml version="1.0" encoding="utf-8"?>
+<p:sld xmlns:a="http://schemas.openxmlformats.org/drawingml/2006/main" xmlns:r="http://schemas.openxmlformats.org/officeDocument/2006/relationships" xmlns:p="http://schemas.openxmlformats.org/presentationml/2006/main">
+  <p:cSld>
+    <p:spTree>
+      <p:nvGrpSpPr>
+        <p:cNvPr id="1" name="">
+          <a:extLst>
+            <a:ext uri="{FF2B5EF4-FFF2-40B4-BE49-F238E27FC236}">
+              <a16:creationId xmlns:a16="http://schemas.microsoft.com/office/drawing/2014/main" id="{2295CAC2-58A6-EF7D-3CCE-35BF33ED50E9}"/>
+            </a:ext>
+          </a:extLst>
+        </p:cNvPr>
+        <p:cNvGrpSpPr/>
+        <p:nvPr/>
+      </p:nvGrpSpPr>
+      <p:grpSpPr>
+        <a:xfrm>
+          <a:off x="0" y="0"/>
+          <a:ext cx="0" cy="0"/>
+          <a:chOff x="0" y="0"/>
+          <a:chExt cx="0" cy="0"/>
+        </a:xfrm>
+      </p:grpSpPr>
+      <p:sp>
+        <p:nvSpPr>
+          <p:cNvPr id="2" name="Título 1">
+            <a:extLst>
+              <a:ext uri="{FF2B5EF4-FFF2-40B4-BE49-F238E27FC236}">
+                <a16:creationId xmlns:a16="http://schemas.microsoft.com/office/drawing/2014/main" id="{CFEB5A8B-ED5C-A16B-8892-0EEAFBF2B984}"/>
+              </a:ext>
+            </a:extLst>
+          </p:cNvPr>
+          <p:cNvSpPr>
+            <a:spLocks noGrp="1"/>
+          </p:cNvSpPr>
+          <p:nvPr>
+            <p:ph type="title"/>
+          </p:nvPr>
+        </p:nvSpPr>
+        <p:spPr/>
+        <p:txBody>
+          <a:bodyPr/>
+          <a:lstStyle/>
+          <a:p>
+            <a:r>
+              <a:rPr lang="es-ES" dirty="0"/>
+              <a:t>Comentarios</a:t>
+            </a:r>
+          </a:p>
+        </p:txBody>
+      </p:sp>
+      <p:sp>
+        <p:nvSpPr>
+          <p:cNvPr id="3" name="Marcador de texto 2">
+            <a:extLst>
+              <a:ext uri="{FF2B5EF4-FFF2-40B4-BE49-F238E27FC236}">
+                <a16:creationId xmlns:a16="http://schemas.microsoft.com/office/drawing/2014/main" id="{E4B9842A-61AB-3A35-1C00-5F7AFB86C4C8}"/>
+              </a:ext>
+            </a:extLst>
+          </p:cNvPr>
+          <p:cNvSpPr>
+            <a:spLocks noGrp="1"/>
+          </p:cNvSpPr>
+          <p:nvPr>
+            <p:ph type="body" idx="1"/>
+          </p:nvPr>
+        </p:nvSpPr>
+        <p:spPr>
+          <a:xfrm>
+            <a:off x="590550" y="685800"/>
+            <a:ext cx="4754899" cy="646331"/>
+          </a:xfrm>
+        </p:spPr>
+        <p:txBody>
+          <a:bodyPr/>
+          <a:lstStyle/>
+          <a:p>
+            <a:r>
+              <a:rPr lang="es-ES" sz="1400" dirty="0"/>
+              <a:t>En este MMI se propagan 15 modos. Los modos [0,1,2,3,4,5,6,7,8,13] son </a:t>
+            </a:r>
+            <a:r>
+              <a:rPr lang="es-ES" sz="1400" dirty="0" err="1"/>
+              <a:t>quasi</a:t>
+            </a:r>
+            <a:r>
+              <a:rPr lang="es-ES" sz="1400" dirty="0"/>
+              <a:t> TE. Y los modos [9,10,11,12,14] son </a:t>
+            </a:r>
+            <a:r>
+              <a:rPr lang="es-ES" sz="1400" dirty="0" err="1"/>
+              <a:t>quasi</a:t>
+            </a:r>
+            <a:r>
+              <a:rPr lang="es-ES" sz="1400" dirty="0"/>
+              <a:t> TM.</a:t>
+            </a:r>
+          </a:p>
+        </p:txBody>
+      </p:sp>
+      <p:sp>
+        <p:nvSpPr>
+          <p:cNvPr id="4" name="Marcador de pie de página 3">
+            <a:extLst>
+              <a:ext uri="{FF2B5EF4-FFF2-40B4-BE49-F238E27FC236}">
+                <a16:creationId xmlns:a16="http://schemas.microsoft.com/office/drawing/2014/main" id="{FF00E62D-7080-2108-8D39-38D8AA716E58}"/>
+              </a:ext>
+            </a:extLst>
+          </p:cNvPr>
+          <p:cNvSpPr>
+            <a:spLocks noGrp="1"/>
+          </p:cNvSpPr>
+          <p:nvPr>
+            <p:ph type="ftr" sz="quarter" idx="5"/>
+          </p:nvPr>
+        </p:nvSpPr>
+        <p:spPr/>
+        <p:txBody>
+          <a:bodyPr/>
+          <a:lstStyle/>
+          <a:p>
+            <a:pPr marL="12700">
+              <a:spcBef>
+                <a:spcPts val="15"/>
+              </a:spcBef>
+            </a:pPr>
+            <a:r>
+              <a:rPr lang="es-ES" spc="-5"/>
+              <a:t>LAB 0.2. COUPLERS</a:t>
+            </a:r>
+            <a:endParaRPr lang="es-ES" spc="-5" dirty="0"/>
+          </a:p>
+        </p:txBody>
+      </p:sp>
+      <p:sp>
+        <p:nvSpPr>
+          <p:cNvPr id="5" name="Marcador de número de diapositiva 4">
+            <a:extLst>
+              <a:ext uri="{FF2B5EF4-FFF2-40B4-BE49-F238E27FC236}">
+                <a16:creationId xmlns:a16="http://schemas.microsoft.com/office/drawing/2014/main" id="{905CC875-3D67-AAEB-8038-4D2011CF92B0}"/>
+              </a:ext>
+            </a:extLst>
+          </p:cNvPr>
+          <p:cNvSpPr>
+            <a:spLocks noGrp="1"/>
+          </p:cNvSpPr>
+          <p:nvPr>
+            <p:ph type="sldNum" sz="quarter" idx="7"/>
+          </p:nvPr>
+        </p:nvSpPr>
+        <p:spPr/>
+        <p:txBody>
+          <a:bodyPr/>
+          <a:lstStyle/>
+          <a:p>
+            <a:fld id="{B6F15528-21DE-4FAA-801E-634DDDAF4B2B}" type="slidenum">
+              <a:rPr lang="es-ES" smtClean="0"/>
+              <a:t>6</a:t>
+            </a:fld>
+            <a:endParaRPr lang="es-ES"/>
+          </a:p>
+        </p:txBody>
+      </p:sp>
+      <p:sp>
+        <p:nvSpPr>
+          <p:cNvPr id="21" name="Marcador de texto 2">
+            <a:extLst>
+              <a:ext uri="{FF2B5EF4-FFF2-40B4-BE49-F238E27FC236}">
+                <a16:creationId xmlns:a16="http://schemas.microsoft.com/office/drawing/2014/main" id="{F8C88E75-503E-6767-1D21-DB325088A954}"/>
+              </a:ext>
+            </a:extLst>
+          </p:cNvPr>
+          <p:cNvSpPr txBox="1">
+            <a:spLocks/>
+          </p:cNvSpPr>
+          <p:nvPr/>
+        </p:nvSpPr>
+        <p:spPr>
+          <a:xfrm>
+            <a:off x="5595946" y="551743"/>
+            <a:ext cx="6400800" cy="1077218"/>
+          </a:xfrm>
+          <a:prstGeom prst="rect">
+            <a:avLst/>
+          </a:prstGeom>
+        </p:spPr>
+        <p:txBody>
+          <a:bodyPr wrap="square" lIns="0" tIns="0" rIns="0" bIns="0">
+            <a:spAutoFit/>
+          </a:bodyPr>
+          <a:lstStyle>
+            <a:lvl1pPr marL="0">
+              <a:defRPr>
+                <a:latin typeface="+mn-lt"/>
+                <a:ea typeface="+mn-ea"/>
+                <a:cs typeface="+mn-cs"/>
+              </a:defRPr>
+            </a:lvl1pPr>
+            <a:lvl2pPr marL="457200">
+              <a:defRPr>
+                <a:latin typeface="+mn-lt"/>
+                <a:ea typeface="+mn-ea"/>
+                <a:cs typeface="+mn-cs"/>
+              </a:defRPr>
+            </a:lvl2pPr>
+            <a:lvl3pPr marL="914400">
+              <a:defRPr>
+                <a:latin typeface="+mn-lt"/>
+                <a:ea typeface="+mn-ea"/>
+                <a:cs typeface="+mn-cs"/>
+              </a:defRPr>
+            </a:lvl3pPr>
+            <a:lvl4pPr marL="1371600">
+              <a:defRPr>
+                <a:latin typeface="+mn-lt"/>
+                <a:ea typeface="+mn-ea"/>
+                <a:cs typeface="+mn-cs"/>
+              </a:defRPr>
+            </a:lvl4pPr>
+            <a:lvl5pPr marL="1828800">
+              <a:defRPr>
+                <a:latin typeface="+mn-lt"/>
+                <a:ea typeface="+mn-ea"/>
+                <a:cs typeface="+mn-cs"/>
+              </a:defRPr>
+            </a:lvl5pPr>
+            <a:lvl6pPr marL="2286000">
+              <a:defRPr>
+                <a:latin typeface="+mn-lt"/>
+                <a:ea typeface="+mn-ea"/>
+                <a:cs typeface="+mn-cs"/>
+              </a:defRPr>
+            </a:lvl6pPr>
+            <a:lvl7pPr marL="2743200">
+              <a:defRPr>
+                <a:latin typeface="+mn-lt"/>
+                <a:ea typeface="+mn-ea"/>
+                <a:cs typeface="+mn-cs"/>
+              </a:defRPr>
+            </a:lvl7pPr>
+            <a:lvl8pPr marL="3200400">
+              <a:defRPr>
+                <a:latin typeface="+mn-lt"/>
+                <a:ea typeface="+mn-ea"/>
+                <a:cs typeface="+mn-cs"/>
+              </a:defRPr>
+            </a:lvl8pPr>
+            <a:lvl9pPr marL="3657600">
+              <a:defRPr>
+                <a:latin typeface="+mn-lt"/>
+                <a:ea typeface="+mn-ea"/>
+                <a:cs typeface="+mn-cs"/>
+              </a:defRPr>
+            </a:lvl9pPr>
+          </a:lstStyle>
+          <a:p>
+            <a:r>
+              <a:rPr lang="es-ES" sz="1400" kern="0" dirty="0">
+                <a:solidFill>
+                  <a:sysClr val="windowText" lastClr="000000"/>
+                </a:solidFill>
+              </a:rPr>
+              <a:t>En cuanto a los </a:t>
+            </a:r>
+            <a:r>
+              <a:rPr lang="es-ES" sz="1400" kern="0" dirty="0" err="1">
+                <a:solidFill>
+                  <a:sysClr val="windowText" lastClr="000000"/>
+                </a:solidFill>
+              </a:rPr>
+              <a:t>plots</a:t>
+            </a:r>
+            <a:r>
+              <a:rPr lang="es-ES" sz="1400" kern="0" dirty="0">
+                <a:solidFill>
+                  <a:sysClr val="windowText" lastClr="000000"/>
+                </a:solidFill>
+              </a:rPr>
+              <a:t>, a parte de identificar el tipo de polarización y corroborar así el calculo y deducción anterior. También se observa que los modos 1 (TE) y 3 (TM) son positivo y negativo. A diferencia de los modos 0 (TE) y 2 (TM) que son positivos.</a:t>
+            </a:r>
+          </a:p>
+          <a:p>
+            <a:endParaRPr lang="es-ES" sz="1400" kern="0" dirty="0">
+              <a:solidFill>
+                <a:sysClr val="windowText" lastClr="000000"/>
+              </a:solidFill>
+            </a:endParaRPr>
+          </a:p>
+          <a:p>
+            <a:endParaRPr lang="es-ES" sz="1400" kern="0" dirty="0">
+              <a:solidFill>
+                <a:sysClr val="windowText" lastClr="000000"/>
+              </a:solidFill>
+            </a:endParaRPr>
+          </a:p>
+        </p:txBody>
+      </p:sp>
+      <mc:AlternateContent xmlns:mc="http://schemas.openxmlformats.org/markup-compatibility/2006">
+        <mc:Choice xmlns:a14="http://schemas.microsoft.com/office/drawing/2010/main" Requires="a14">
+          <p:sp>
+            <p:nvSpPr>
+              <p:cNvPr id="22" name="CuadroTexto 21">
+                <a:extLst>
+                  <a:ext uri="{FF2B5EF4-FFF2-40B4-BE49-F238E27FC236}">
+                    <a16:creationId xmlns:a16="http://schemas.microsoft.com/office/drawing/2014/main" id="{17B00E25-B634-E827-0FDD-A9F95F3AB64C}"/>
+                  </a:ext>
+                </a:extLst>
+              </p:cNvPr>
+              <p:cNvSpPr txBox="1"/>
+              <p:nvPr/>
+            </p:nvSpPr>
+            <p:spPr>
+              <a:xfrm>
+                <a:off x="457200" y="4543739"/>
+                <a:ext cx="10941309" cy="1446550"/>
+              </a:xfrm>
+              <a:prstGeom prst="rect">
+                <a:avLst/>
+              </a:prstGeom>
+              <a:noFill/>
+            </p:spPr>
+            <p:txBody>
+              <a:bodyPr wrap="square" rtlCol="0">
+                <a:spAutoFit/>
+              </a:bodyPr>
+              <a:lstStyle/>
+              <a:p>
+                <a:r>
+                  <a:rPr lang="es-ES" sz="1400" dirty="0"/>
+                  <a:t>Cuando calculamos la longitud de batido, que es la distancia </a:t>
+                </a:r>
+                <a:r>
+                  <a:rPr lang="es-ES" sz="1400" dirty="0" err="1"/>
+                  <a:t>minima</a:t>
+                </a:r>
+                <a:r>
+                  <a:rPr lang="es-ES" sz="1400" dirty="0"/>
+                  <a:t> para transferir la </a:t>
+                </a:r>
+                <a:r>
+                  <a:rPr lang="es-ES" sz="1400" dirty="0" err="1"/>
+                  <a:t>energia</a:t>
+                </a:r>
+                <a:r>
+                  <a:rPr lang="es-ES" sz="1400" dirty="0"/>
+                  <a:t> a la </a:t>
+                </a:r>
+                <a:r>
+                  <a:rPr lang="es-ES" sz="1400" dirty="0" err="1"/>
+                  <a:t>guia</a:t>
+                </a:r>
+                <a:r>
+                  <a:rPr lang="es-ES" sz="1400" dirty="0"/>
+                  <a:t> contraria, la cual depende del gap y de la diferencia de índices. Se observa que tenemos dependencia de la polarización del sistema ya que para los modos TE la </a:t>
+                </a:r>
+                <a14:m>
+                  <m:oMath xmlns:m="http://schemas.openxmlformats.org/officeDocument/2006/math">
+                    <m:sSub>
+                      <m:sSubPr>
+                        <m:ctrlPr>
+                          <a:rPr lang="es-ES" sz="1100" b="1" i="1" smtClean="0">
+                            <a:latin typeface="Cambria Math" panose="02040503050406030204" pitchFamily="18" charset="0"/>
+                          </a:rPr>
+                        </m:ctrlPr>
+                      </m:sSubPr>
+                      <m:e>
+                        <m:r>
+                          <a:rPr lang="es-ES" sz="1100" b="1" i="1" smtClean="0">
+                            <a:latin typeface="Cambria Math" panose="02040503050406030204" pitchFamily="18" charset="0"/>
+                          </a:rPr>
+                          <m:t>𝑳</m:t>
+                        </m:r>
+                      </m:e>
+                      <m:sub>
+                        <m:r>
+                          <a:rPr lang="es-ES" sz="1100" b="1" i="1" smtClean="0">
+                            <a:latin typeface="Cambria Math" panose="02040503050406030204" pitchFamily="18" charset="0"/>
+                            <a:ea typeface="Cambria Math" panose="02040503050406030204" pitchFamily="18" charset="0"/>
+                          </a:rPr>
+                          <m:t>𝝅</m:t>
+                        </m:r>
+                      </m:sub>
+                    </m:sSub>
+                    <m:r>
+                      <a:rPr lang="es-ES" sz="1100" b="1" i="1" smtClean="0">
+                        <a:latin typeface="Cambria Math" panose="02040503050406030204" pitchFamily="18" charset="0"/>
+                      </a:rPr>
+                      <m:t>=</m:t>
+                    </m:r>
+                    <m:r>
+                      <m:rPr>
+                        <m:nor/>
+                      </m:rPr>
+                      <a:rPr lang="es-ES" sz="1400" b="1"/>
+                      <m:t>93.83767536700753</m:t>
+                    </m:r>
+                  </m:oMath>
+                </a14:m>
+                <a:r>
+                  <a:rPr lang="es-ES" sz="1400" dirty="0"/>
+                  <a:t> </a:t>
+                </a:r>
+                <a:r>
+                  <a:rPr lang="es-ES" sz="1400" b="1" dirty="0"/>
+                  <a:t>nm</a:t>
+                </a:r>
+                <a:r>
+                  <a:rPr lang="es-ES" sz="1400" dirty="0"/>
+                  <a:t> y para los modos TM la </a:t>
+                </a:r>
+                <a14:m>
+                  <m:oMath xmlns:m="http://schemas.openxmlformats.org/officeDocument/2006/math">
+                    <m:sSub>
+                      <m:sSubPr>
+                        <m:ctrlPr>
+                          <a:rPr lang="es-ES" sz="1000" b="1" i="1">
+                            <a:latin typeface="Cambria Math" panose="02040503050406030204" pitchFamily="18" charset="0"/>
+                          </a:rPr>
+                        </m:ctrlPr>
+                      </m:sSubPr>
+                      <m:e>
+                        <m:r>
+                          <a:rPr lang="es-ES" sz="1000" b="1" i="1">
+                            <a:latin typeface="Cambria Math" panose="02040503050406030204" pitchFamily="18" charset="0"/>
+                          </a:rPr>
+                          <m:t>𝑳</m:t>
+                        </m:r>
+                      </m:e>
+                      <m:sub>
+                        <m:r>
+                          <a:rPr lang="es-ES" sz="1000" b="1" i="1">
+                            <a:latin typeface="Cambria Math" panose="02040503050406030204" pitchFamily="18" charset="0"/>
+                            <a:ea typeface="Cambria Math" panose="02040503050406030204" pitchFamily="18" charset="0"/>
+                          </a:rPr>
+                          <m:t>𝝅</m:t>
+                        </m:r>
+                      </m:sub>
+                    </m:sSub>
+                    <m:r>
+                      <a:rPr lang="es-ES" sz="1000" b="1" i="1">
+                        <a:latin typeface="Cambria Math" panose="02040503050406030204" pitchFamily="18" charset="0"/>
+                      </a:rPr>
+                      <m:t>=</m:t>
+                    </m:r>
+                    <m:r>
+                      <m:rPr>
+                        <m:nor/>
+                      </m:rPr>
+                      <a:rPr lang="es-ES" sz="1400" b="1"/>
+                      <m:t>52.26022367744142</m:t>
+                    </m:r>
+                    <m:r>
+                      <m:rPr>
+                        <m:nor/>
+                      </m:rPr>
+                      <a:rPr lang="es-ES" sz="1400" b="1" i="0" smtClean="0"/>
+                      <m:t> </m:t>
+                    </m:r>
+                    <m:r>
+                      <m:rPr>
+                        <m:nor/>
+                      </m:rPr>
+                      <a:rPr lang="es-ES" sz="1400" b="1" i="0" smtClean="0"/>
+                      <m:t>nm</m:t>
+                    </m:r>
+                    <m:r>
+                      <m:rPr>
+                        <m:nor/>
+                      </m:rPr>
+                      <a:rPr lang="es-ES" sz="1400" b="1" i="0" smtClean="0"/>
+                      <m:t>.</m:t>
+                    </m:r>
+                  </m:oMath>
+                </a14:m>
+                <a:r>
+                  <a:rPr lang="es-ES" sz="1400" dirty="0"/>
+                  <a:t> Es decir, si se diseña un dispositivo para TE con su respectiva longitud pero erróneamente llevamos una </a:t>
+                </a:r>
+                <a:r>
+                  <a:rPr lang="es-ES" sz="1400" dirty="0" err="1"/>
+                  <a:t>polarizacion</a:t>
+                </a:r>
+                <a:r>
+                  <a:rPr lang="es-ES" sz="1400" dirty="0"/>
+                  <a:t> TM, el resultado no será el esperado.</a:t>
+                </a:r>
+              </a:p>
+              <a:p>
+                <a:r>
+                  <a:rPr lang="es-ES" sz="1400" dirty="0"/>
+                  <a:t>Es mejor hacer el calculo a mano porque GDS da por hecho que el modo 0 es TE y el 1 es TM es </a:t>
+                </a:r>
+                <a:r>
+                  <a:rPr lang="es-ES" sz="1400" dirty="0" err="1"/>
+                  <a:t>asi</a:t>
+                </a:r>
+                <a:r>
+                  <a:rPr lang="es-ES" sz="1400" dirty="0"/>
+                  <a:t> siempre y no es cierto</a:t>
+                </a:r>
+              </a:p>
+              <a:p>
+                <a:endParaRPr lang="es-ES" dirty="0"/>
+              </a:p>
+            </p:txBody>
+          </p:sp>
+        </mc:Choice>
+        <mc:Fallback>
+          <p:sp>
+            <p:nvSpPr>
+              <p:cNvPr id="22" name="CuadroTexto 21">
+                <a:extLst>
+                  <a:ext uri="{FF2B5EF4-FFF2-40B4-BE49-F238E27FC236}">
+                    <a16:creationId xmlns:a16="http://schemas.microsoft.com/office/drawing/2014/main" id="{17B00E25-B634-E827-0FDD-A9F95F3AB64C}"/>
+                  </a:ext>
+                </a:extLst>
+              </p:cNvPr>
+              <p:cNvSpPr txBox="1">
+                <a:spLocks noRot="1" noChangeAspect="1" noMove="1" noResize="1" noEditPoints="1" noAdjustHandles="1" noChangeArrowheads="1" noChangeShapeType="1" noTextEdit="1"/>
+              </p:cNvSpPr>
+              <p:nvPr/>
+            </p:nvSpPr>
+            <p:spPr>
+              <a:xfrm>
+                <a:off x="457200" y="4543739"/>
+                <a:ext cx="10941309" cy="1446550"/>
+              </a:xfrm>
+              <a:prstGeom prst="rect">
+                <a:avLst/>
+              </a:prstGeom>
+              <a:blipFill>
+                <a:blip r:embed="rId2"/>
+                <a:stretch>
+                  <a:fillRect l="-167" t="-420"/>
+                </a:stretch>
+              </a:blipFill>
+            </p:spPr>
+            <p:txBody>
+              <a:bodyPr/>
+              <a:lstStyle/>
+              <a:p>
+                <a:r>
+                  <a:rPr lang="es-ES">
+                    <a:noFill/>
+                  </a:rPr>
+                  <a:t> </a:t>
+                </a:r>
+              </a:p>
+            </p:txBody>
+          </p:sp>
+        </mc:Fallback>
+      </mc:AlternateContent>
+      <p:pic>
+        <p:nvPicPr>
+          <p:cNvPr id="7" name="Imagen 6" descr="Texto&#10;&#10;El contenido generado por IA puede ser incorrecto.">
+            <a:extLst>
+              <a:ext uri="{FF2B5EF4-FFF2-40B4-BE49-F238E27FC236}">
+                <a16:creationId xmlns:a16="http://schemas.microsoft.com/office/drawing/2014/main" id="{E390FECF-6073-AD6D-601B-A0419EC01645}"/>
+              </a:ext>
+            </a:extLst>
+          </p:cNvPr>
+          <p:cNvPicPr>
+            <a:picLocks noChangeAspect="1"/>
+          </p:cNvPicPr>
+          <p:nvPr/>
+        </p:nvPicPr>
+        <p:blipFill>
+          <a:blip r:embed="rId3"/>
+          <a:stretch>
+            <a:fillRect/>
+          </a:stretch>
+        </p:blipFill>
+        <p:spPr>
+          <a:xfrm>
+            <a:off x="590550" y="1631740"/>
+            <a:ext cx="4318908" cy="2524348"/>
+          </a:xfrm>
+          <a:prstGeom prst="rect">
+            <a:avLst/>
+          </a:prstGeom>
+        </p:spPr>
+      </p:pic>
+      <mc:AlternateContent xmlns:mc="http://schemas.openxmlformats.org/markup-compatibility/2006">
+        <mc:Choice xmlns:p14="http://schemas.microsoft.com/office/powerpoint/2010/main" Requires="p14">
+          <p:contentPart p14:bwMode="auto" r:id="rId4">
+            <p14:nvContentPartPr>
+              <p14:cNvPr id="8" name="Entrada de lápiz 7">
+                <a:extLst>
+                  <a:ext uri="{FF2B5EF4-FFF2-40B4-BE49-F238E27FC236}">
+                    <a16:creationId xmlns:a16="http://schemas.microsoft.com/office/drawing/2014/main" id="{B79827AE-57B3-1B01-1112-4ED8D7F9022E}"/>
+                  </a:ext>
+                </a:extLst>
+              </p14:cNvPr>
+              <p14:cNvContentPartPr/>
+              <p14:nvPr/>
+            </p14:nvContentPartPr>
+            <p14:xfrm>
+              <a:off x="1184973" y="2173070"/>
+              <a:ext cx="3647520" cy="57240"/>
+            </p14:xfrm>
+          </p:contentPart>
+        </mc:Choice>
+        <mc:Fallback>
+          <p:pic>
+            <p:nvPicPr>
+              <p:cNvPr id="8" name="Entrada de lápiz 7">
+                <a:extLst>
+                  <a:ext uri="{FF2B5EF4-FFF2-40B4-BE49-F238E27FC236}">
+                    <a16:creationId xmlns:a16="http://schemas.microsoft.com/office/drawing/2014/main" id="{B79827AE-57B3-1B01-1112-4ED8D7F9022E}"/>
+                  </a:ext>
+                </a:extLst>
+              </p:cNvPr>
+              <p:cNvPicPr/>
+              <p:nvPr/>
+            </p:nvPicPr>
+            <p:blipFill>
+              <a:blip r:embed="rId5"/>
+              <a:stretch>
+                <a:fillRect/>
+              </a:stretch>
+            </p:blipFill>
+            <p:spPr>
+              <a:xfrm>
+                <a:off x="1130973" y="2065070"/>
+                <a:ext cx="3755160" cy="272880"/>
+              </a:xfrm>
+              <a:prstGeom prst="rect">
+                <a:avLst/>
+              </a:prstGeom>
+            </p:spPr>
+          </p:pic>
+        </mc:Fallback>
+      </mc:AlternateContent>
+      <mc:AlternateContent xmlns:mc="http://schemas.openxmlformats.org/markup-compatibility/2006">
+        <mc:Choice xmlns:p14="http://schemas.microsoft.com/office/powerpoint/2010/main" Requires="p14">
+          <p:contentPart p14:bwMode="auto" r:id="rId6">
+            <p14:nvContentPartPr>
+              <p14:cNvPr id="14" name="Entrada de lápiz 13">
+                <a:extLst>
+                  <a:ext uri="{FF2B5EF4-FFF2-40B4-BE49-F238E27FC236}">
+                    <a16:creationId xmlns:a16="http://schemas.microsoft.com/office/drawing/2014/main" id="{9D4BA834-3D4A-40E1-5340-C43FF030CB3F}"/>
+                  </a:ext>
+                </a:extLst>
+              </p14:cNvPr>
+              <p14:cNvContentPartPr/>
+              <p14:nvPr/>
+            </p14:nvContentPartPr>
+            <p14:xfrm>
+              <a:off x="1127580" y="2486340"/>
+              <a:ext cx="858960" cy="28440"/>
+            </p14:xfrm>
+          </p:contentPart>
+        </mc:Choice>
+        <mc:Fallback>
+          <p:pic>
+            <p:nvPicPr>
+              <p:cNvPr id="14" name="Entrada de lápiz 13">
+                <a:extLst>
+                  <a:ext uri="{FF2B5EF4-FFF2-40B4-BE49-F238E27FC236}">
+                    <a16:creationId xmlns:a16="http://schemas.microsoft.com/office/drawing/2014/main" id="{9D4BA834-3D4A-40E1-5340-C43FF030CB3F}"/>
+                  </a:ext>
+                </a:extLst>
+              </p:cNvPr>
+              <p:cNvPicPr/>
+              <p:nvPr/>
+            </p:nvPicPr>
+            <p:blipFill>
+              <a:blip r:embed="rId7"/>
+              <a:stretch>
+                <a:fillRect/>
+              </a:stretch>
+            </p:blipFill>
+            <p:spPr>
+              <a:xfrm>
+                <a:off x="1073580" y="2378700"/>
+                <a:ext cx="966600" cy="244080"/>
+              </a:xfrm>
+              <a:prstGeom prst="rect">
+                <a:avLst/>
+              </a:prstGeom>
+            </p:spPr>
+          </p:pic>
+        </mc:Fallback>
+      </mc:AlternateContent>
+      <mc:AlternateContent xmlns:mc="http://schemas.openxmlformats.org/markup-compatibility/2006">
+        <mc:Choice xmlns:p14="http://schemas.microsoft.com/office/powerpoint/2010/main" Requires="p14">
+          <p:contentPart p14:bwMode="auto" r:id="rId8">
+            <p14:nvContentPartPr>
+              <p14:cNvPr id="16" name="Entrada de lápiz 15">
+                <a:extLst>
+                  <a:ext uri="{FF2B5EF4-FFF2-40B4-BE49-F238E27FC236}">
+                    <a16:creationId xmlns:a16="http://schemas.microsoft.com/office/drawing/2014/main" id="{00A9D6AA-FBE0-B8A7-9C2D-1DD1228910FD}"/>
+                  </a:ext>
+                </a:extLst>
+              </p14:cNvPr>
+              <p14:cNvContentPartPr/>
+              <p14:nvPr/>
+            </p14:nvContentPartPr>
+            <p14:xfrm>
+              <a:off x="2085180" y="2687220"/>
+              <a:ext cx="801720" cy="31320"/>
+            </p14:xfrm>
+          </p:contentPart>
+        </mc:Choice>
+        <mc:Fallback>
+          <p:pic>
+            <p:nvPicPr>
+              <p:cNvPr id="16" name="Entrada de lápiz 15">
+                <a:extLst>
+                  <a:ext uri="{FF2B5EF4-FFF2-40B4-BE49-F238E27FC236}">
+                    <a16:creationId xmlns:a16="http://schemas.microsoft.com/office/drawing/2014/main" id="{00A9D6AA-FBE0-B8A7-9C2D-1DD1228910FD}"/>
+                  </a:ext>
+                </a:extLst>
+              </p:cNvPr>
+              <p:cNvPicPr/>
+              <p:nvPr/>
+            </p:nvPicPr>
+            <p:blipFill>
+              <a:blip r:embed="rId9"/>
+              <a:stretch>
+                <a:fillRect/>
+              </a:stretch>
+            </p:blipFill>
+            <p:spPr>
+              <a:xfrm>
+                <a:off x="2031180" y="2579220"/>
+                <a:ext cx="909360" cy="246960"/>
+              </a:xfrm>
+              <a:prstGeom prst="rect">
+                <a:avLst/>
+              </a:prstGeom>
+            </p:spPr>
+          </p:pic>
+        </mc:Fallback>
+      </mc:AlternateContent>
+      <mc:AlternateContent xmlns:mc="http://schemas.openxmlformats.org/markup-compatibility/2006">
+        <mc:Choice xmlns:p14="http://schemas.microsoft.com/office/powerpoint/2010/main" Requires="p14">
+          <p:contentPart p14:bwMode="auto" r:id="rId10">
+            <p14:nvContentPartPr>
+              <p14:cNvPr id="20" name="Entrada de lápiz 19">
+                <a:extLst>
+                  <a:ext uri="{FF2B5EF4-FFF2-40B4-BE49-F238E27FC236}">
+                    <a16:creationId xmlns:a16="http://schemas.microsoft.com/office/drawing/2014/main" id="{005CD1C6-5B91-FD11-6A6C-7EB5FE62658F}"/>
+                  </a:ext>
+                </a:extLst>
+              </p14:cNvPr>
+              <p14:cNvContentPartPr/>
+              <p14:nvPr/>
+            </p14:nvContentPartPr>
+            <p14:xfrm>
+              <a:off x="2074740" y="2361780"/>
+              <a:ext cx="2677680" cy="720"/>
+            </p14:xfrm>
+          </p:contentPart>
+        </mc:Choice>
+        <mc:Fallback>
+          <p:pic>
+            <p:nvPicPr>
+              <p:cNvPr id="20" name="Entrada de lápiz 19">
+                <a:extLst>
+                  <a:ext uri="{FF2B5EF4-FFF2-40B4-BE49-F238E27FC236}">
+                    <a16:creationId xmlns:a16="http://schemas.microsoft.com/office/drawing/2014/main" id="{005CD1C6-5B91-FD11-6A6C-7EB5FE62658F}"/>
+                  </a:ext>
+                </a:extLst>
+              </p:cNvPr>
+              <p:cNvPicPr/>
+              <p:nvPr/>
+            </p:nvPicPr>
+            <p:blipFill>
+              <a:blip r:embed="rId11"/>
+              <a:stretch>
+                <a:fillRect/>
+              </a:stretch>
+            </p:blipFill>
+            <p:spPr>
+              <a:xfrm>
+                <a:off x="2021100" y="2145780"/>
+                <a:ext cx="2785320" cy="432000"/>
+              </a:xfrm>
+              <a:prstGeom prst="rect">
+                <a:avLst/>
+              </a:prstGeom>
+            </p:spPr>
+          </p:pic>
+        </mc:Fallback>
+      </mc:AlternateContent>
+      <mc:AlternateContent xmlns:mc="http://schemas.openxmlformats.org/markup-compatibility/2006">
+        <mc:Choice xmlns:p14="http://schemas.microsoft.com/office/powerpoint/2010/main" Requires="p14">
+          <p:contentPart p14:bwMode="auto" r:id="rId12">
+            <p14:nvContentPartPr>
+              <p14:cNvPr id="23" name="Entrada de lápiz 22">
+                <a:extLst>
+                  <a:ext uri="{FF2B5EF4-FFF2-40B4-BE49-F238E27FC236}">
+                    <a16:creationId xmlns:a16="http://schemas.microsoft.com/office/drawing/2014/main" id="{6636CF1A-A802-2E93-8E79-A04AEE05E725}"/>
+                  </a:ext>
+                </a:extLst>
+              </p14:cNvPr>
+              <p14:cNvContentPartPr/>
+              <p14:nvPr/>
+            </p14:nvContentPartPr>
+            <p14:xfrm>
+              <a:off x="1142700" y="2326140"/>
+              <a:ext cx="851040" cy="18720"/>
+            </p14:xfrm>
+          </p:contentPart>
+        </mc:Choice>
+        <mc:Fallback>
+          <p:pic>
+            <p:nvPicPr>
+              <p:cNvPr id="23" name="Entrada de lápiz 22">
+                <a:extLst>
+                  <a:ext uri="{FF2B5EF4-FFF2-40B4-BE49-F238E27FC236}">
+                    <a16:creationId xmlns:a16="http://schemas.microsoft.com/office/drawing/2014/main" id="{6636CF1A-A802-2E93-8E79-A04AEE05E725}"/>
+                  </a:ext>
+                </a:extLst>
+              </p:cNvPr>
+              <p:cNvPicPr/>
+              <p:nvPr/>
+            </p:nvPicPr>
+            <p:blipFill>
+              <a:blip r:embed="rId13"/>
+              <a:stretch>
+                <a:fillRect/>
+              </a:stretch>
+            </p:blipFill>
+            <p:spPr>
+              <a:xfrm>
+                <a:off x="1089060" y="2218140"/>
+                <a:ext cx="958680" cy="234360"/>
+              </a:xfrm>
+              <a:prstGeom prst="rect">
+                <a:avLst/>
+              </a:prstGeom>
+            </p:spPr>
+          </p:pic>
+        </mc:Fallback>
+      </mc:AlternateContent>
+      <mc:AlternateContent xmlns:mc="http://schemas.openxmlformats.org/markup-compatibility/2006">
+        <mc:Choice xmlns:p14="http://schemas.microsoft.com/office/powerpoint/2010/main" Requires="p14">
+          <p:contentPart p14:bwMode="auto" r:id="rId14">
+            <p14:nvContentPartPr>
+              <p14:cNvPr id="26" name="Entrada de lápiz 25">
+                <a:extLst>
+                  <a:ext uri="{FF2B5EF4-FFF2-40B4-BE49-F238E27FC236}">
+                    <a16:creationId xmlns:a16="http://schemas.microsoft.com/office/drawing/2014/main" id="{36588DB4-A42E-2584-EDE6-C2165D692BE6}"/>
+                  </a:ext>
+                </a:extLst>
+              </p14:cNvPr>
+              <p14:cNvContentPartPr/>
+              <p14:nvPr/>
+            </p14:nvContentPartPr>
+            <p14:xfrm>
+              <a:off x="2090120" y="3875800"/>
+              <a:ext cx="2766600" cy="720"/>
+            </p14:xfrm>
+          </p:contentPart>
+        </mc:Choice>
+        <mc:Fallback>
+          <p:pic>
+            <p:nvPicPr>
+              <p:cNvPr id="26" name="Entrada de lápiz 25">
+                <a:extLst>
+                  <a:ext uri="{FF2B5EF4-FFF2-40B4-BE49-F238E27FC236}">
+                    <a16:creationId xmlns:a16="http://schemas.microsoft.com/office/drawing/2014/main" id="{36588DB4-A42E-2584-EDE6-C2165D692BE6}"/>
+                  </a:ext>
+                </a:extLst>
+              </p:cNvPr>
+              <p:cNvPicPr/>
+              <p:nvPr/>
+            </p:nvPicPr>
+            <p:blipFill>
+              <a:blip r:embed="rId15"/>
+              <a:stretch>
+                <a:fillRect/>
+              </a:stretch>
+            </p:blipFill>
+            <p:spPr>
+              <a:xfrm>
+                <a:off x="2054120" y="3731800"/>
+                <a:ext cx="2838240" cy="288000"/>
+              </a:xfrm>
+              <a:prstGeom prst="rect">
+                <a:avLst/>
+              </a:prstGeom>
+            </p:spPr>
+          </p:pic>
+        </mc:Fallback>
+      </mc:AlternateContent>
+      <mc:AlternateContent xmlns:mc="http://schemas.openxmlformats.org/markup-compatibility/2006">
+        <mc:Choice xmlns:p14="http://schemas.microsoft.com/office/powerpoint/2010/main" Requires="p14">
+          <p:contentPart p14:bwMode="auto" r:id="rId16">
+            <p14:nvContentPartPr>
+              <p14:cNvPr id="27" name="Entrada de lápiz 26">
+                <a:extLst>
+                  <a:ext uri="{FF2B5EF4-FFF2-40B4-BE49-F238E27FC236}">
+                    <a16:creationId xmlns:a16="http://schemas.microsoft.com/office/drawing/2014/main" id="{AC968FD6-436E-2EF2-BBE9-FF3C73A1E012}"/>
+                  </a:ext>
+                </a:extLst>
+              </p14:cNvPr>
+              <p14:cNvContentPartPr/>
+              <p14:nvPr/>
+            </p14:nvContentPartPr>
+            <p14:xfrm>
+              <a:off x="1112360" y="4009360"/>
+              <a:ext cx="893880" cy="30600"/>
+            </p14:xfrm>
+          </p:contentPart>
+        </mc:Choice>
+        <mc:Fallback>
+          <p:pic>
+            <p:nvPicPr>
+              <p:cNvPr id="27" name="Entrada de lápiz 26">
+                <a:extLst>
+                  <a:ext uri="{FF2B5EF4-FFF2-40B4-BE49-F238E27FC236}">
+                    <a16:creationId xmlns:a16="http://schemas.microsoft.com/office/drawing/2014/main" id="{AC968FD6-436E-2EF2-BBE9-FF3C73A1E012}"/>
+                  </a:ext>
+                </a:extLst>
+              </p:cNvPr>
+              <p:cNvPicPr/>
+              <p:nvPr/>
+            </p:nvPicPr>
+            <p:blipFill>
+              <a:blip r:embed="rId17"/>
+              <a:stretch>
+                <a:fillRect/>
+              </a:stretch>
+            </p:blipFill>
+            <p:spPr>
+              <a:xfrm>
+                <a:off x="1076360" y="3937720"/>
+                <a:ext cx="965520" cy="174240"/>
+              </a:xfrm>
+              <a:prstGeom prst="rect">
+                <a:avLst/>
+              </a:prstGeom>
+            </p:spPr>
+          </p:pic>
+        </mc:Fallback>
+      </mc:AlternateContent>
+      <mc:AlternateContent xmlns:mc="http://schemas.openxmlformats.org/markup-compatibility/2006">
+        <mc:Choice xmlns:p14="http://schemas.microsoft.com/office/powerpoint/2010/main" Requires="p14">
+          <p:contentPart p14:bwMode="auto" r:id="rId18">
+            <p14:nvContentPartPr>
+              <p14:cNvPr id="28" name="Entrada de lápiz 27">
+                <a:extLst>
+                  <a:ext uri="{FF2B5EF4-FFF2-40B4-BE49-F238E27FC236}">
+                    <a16:creationId xmlns:a16="http://schemas.microsoft.com/office/drawing/2014/main" id="{2926D18C-8140-0DCE-49F3-6D6EC9999CF7}"/>
+                  </a:ext>
+                </a:extLst>
+              </p14:cNvPr>
+              <p14:cNvContentPartPr/>
+              <p14:nvPr/>
+            </p14:nvContentPartPr>
+            <p14:xfrm>
+              <a:off x="3030080" y="4007920"/>
+              <a:ext cx="843480" cy="44280"/>
+            </p14:xfrm>
+          </p:contentPart>
+        </mc:Choice>
+        <mc:Fallback>
+          <p:pic>
+            <p:nvPicPr>
+              <p:cNvPr id="28" name="Entrada de lápiz 27">
+                <a:extLst>
+                  <a:ext uri="{FF2B5EF4-FFF2-40B4-BE49-F238E27FC236}">
+                    <a16:creationId xmlns:a16="http://schemas.microsoft.com/office/drawing/2014/main" id="{2926D18C-8140-0DCE-49F3-6D6EC9999CF7}"/>
+                  </a:ext>
+                </a:extLst>
+              </p:cNvPr>
+              <p:cNvPicPr/>
+              <p:nvPr/>
+            </p:nvPicPr>
+            <p:blipFill>
+              <a:blip r:embed="rId19"/>
+              <a:stretch>
+                <a:fillRect/>
+              </a:stretch>
+            </p:blipFill>
+            <p:spPr>
+              <a:xfrm>
+                <a:off x="2994080" y="3936280"/>
+                <a:ext cx="915120" cy="187920"/>
+              </a:xfrm>
+              <a:prstGeom prst="rect">
+                <a:avLst/>
+              </a:prstGeom>
+            </p:spPr>
+          </p:pic>
+        </mc:Fallback>
+      </mc:AlternateContent>
+    </p:spTree>
+    <p:extLst>
+      <p:ext uri="{BB962C8B-B14F-4D97-AF65-F5344CB8AC3E}">
+        <p14:creationId xmlns:p14="http://schemas.microsoft.com/office/powerpoint/2010/main" val="3293975533"/>
+      </p:ext>
+    </p:extLst>
+  </p:cSld>
+  <p:clrMapOvr>
+    <a:masterClrMapping/>
+  </p:clrMapOvr>
+</p:sld>
+</file>
+
+<file path=ppt/slides/slide7.xml><?xml version="1.0" encoding="utf-8"?>
 <p:sld xmlns:a="http://schemas.openxmlformats.org/drawingml/2006/main" xmlns:r="http://schemas.openxmlformats.org/officeDocument/2006/relationships" xmlns:p="http://schemas.openxmlformats.org/presentationml/2006/main">
   <p:cSld>
     <p:spTree>
@@ -5857,7 +8534,7 @@
           <a:p>
             <a:fld id="{B6F15528-21DE-4FAA-801E-634DDDAF4B2B}" type="slidenum">
               <a:rPr lang="es-ES" smtClean="0"/>
-              <a:t>5</a:t>
+              <a:t>7</a:t>
             </a:fld>
             <a:endParaRPr lang="es-ES"/>
           </a:p>

</xml_diff>